<commit_message>
Verify Group 4 preview and harden final submission gates
</commit_message>
<xml_diff>
--- a/deliverables/CoupledCF_presentation.pptx
+++ b/deliverables/CoupledCF_presentation.pptx
@@ -2,28 +2,28 @@
 <file path=ppt/presentation.xml><?xml version="1.0" encoding="utf-8"?>
 <p:presentation xmlns:p="http://schemas.openxmlformats.org/presentationml/2006/main">
   <p:sldMasterIdLst>
-    <p:sldMasterId xmlns:r="http://schemas.openxmlformats.org/officeDocument/2006/relationships" id="2147483648" r:id="R6dcab340f4e246a4"/>
+    <p:sldMasterId xmlns:r="http://schemas.openxmlformats.org/officeDocument/2006/relationships" id="2147483648" r:id="Ra04e80058ba14ed5"/>
   </p:sldMasterIdLst>
   <p:notesMasterIdLst>
-    <p:notesMasterId xmlns:r="http://schemas.openxmlformats.org/officeDocument/2006/relationships" r:id="Rab606549306e445b"/>
+    <p:notesMasterId xmlns:r="http://schemas.openxmlformats.org/officeDocument/2006/relationships" r:id="R89d4a5a01a0649ac"/>
   </p:notesMasterIdLst>
   <p:sldIdLst>
-    <p:sldId xmlns:r="http://schemas.openxmlformats.org/officeDocument/2006/relationships" id="256" r:id="R9b2332b3e1da420c"/>
-    <p:sldId xmlns:r="http://schemas.openxmlformats.org/officeDocument/2006/relationships" id="257" r:id="R3135066eb3ba4175"/>
-    <p:sldId xmlns:r="http://schemas.openxmlformats.org/officeDocument/2006/relationships" id="258" r:id="R74fcd3beca6a4cbe"/>
-    <p:sldId xmlns:r="http://schemas.openxmlformats.org/officeDocument/2006/relationships" id="259" r:id="Rc1689b9675ad49c0"/>
-    <p:sldId xmlns:r="http://schemas.openxmlformats.org/officeDocument/2006/relationships" id="260" r:id="R0d8eea40547f4ec5"/>
-    <p:sldId xmlns:r="http://schemas.openxmlformats.org/officeDocument/2006/relationships" id="261" r:id="Rda7fffe0e718458e"/>
-    <p:sldId xmlns:r="http://schemas.openxmlformats.org/officeDocument/2006/relationships" id="262" r:id="R1b810f6006d24e25"/>
-    <p:sldId xmlns:r="http://schemas.openxmlformats.org/officeDocument/2006/relationships" id="263" r:id="R71d2c5bfc20a40cb"/>
-    <p:sldId xmlns:r="http://schemas.openxmlformats.org/officeDocument/2006/relationships" id="264" r:id="R5717797b2c064776"/>
-    <p:sldId xmlns:r="http://schemas.openxmlformats.org/officeDocument/2006/relationships" id="265" r:id="R899f3f26eebc418d"/>
-    <p:sldId xmlns:r="http://schemas.openxmlformats.org/officeDocument/2006/relationships" id="266" r:id="R54efffcdf8854da2"/>
-    <p:sldId xmlns:r="http://schemas.openxmlformats.org/officeDocument/2006/relationships" id="267" r:id="Ra87dacfd0e5a477f"/>
-    <p:sldId xmlns:r="http://schemas.openxmlformats.org/officeDocument/2006/relationships" id="268" r:id="R36fdb00e1e484dd2"/>
-    <p:sldId xmlns:r="http://schemas.openxmlformats.org/officeDocument/2006/relationships" id="269" r:id="R7563ef78a89a4a98"/>
-    <p:sldId xmlns:r="http://schemas.openxmlformats.org/officeDocument/2006/relationships" id="270" r:id="Ra430b6fcde0245ce"/>
-    <p:sldId xmlns:r="http://schemas.openxmlformats.org/officeDocument/2006/relationships" id="271" r:id="Rdbd4b11a250746b4"/>
+    <p:sldId xmlns:r="http://schemas.openxmlformats.org/officeDocument/2006/relationships" id="256" r:id="R7189116c837e4e4a"/>
+    <p:sldId xmlns:r="http://schemas.openxmlformats.org/officeDocument/2006/relationships" id="257" r:id="Re093e38420844d51"/>
+    <p:sldId xmlns:r="http://schemas.openxmlformats.org/officeDocument/2006/relationships" id="258" r:id="Re1867c4968ff4648"/>
+    <p:sldId xmlns:r="http://schemas.openxmlformats.org/officeDocument/2006/relationships" id="259" r:id="Reefb83ce2a7c4ec9"/>
+    <p:sldId xmlns:r="http://schemas.openxmlformats.org/officeDocument/2006/relationships" id="260" r:id="Ra4bfe3448f424ad2"/>
+    <p:sldId xmlns:r="http://schemas.openxmlformats.org/officeDocument/2006/relationships" id="261" r:id="R8a00fd51a7c24852"/>
+    <p:sldId xmlns:r="http://schemas.openxmlformats.org/officeDocument/2006/relationships" id="262" r:id="R690057c2ae5746f7"/>
+    <p:sldId xmlns:r="http://schemas.openxmlformats.org/officeDocument/2006/relationships" id="263" r:id="Re153061bdb3c44b2"/>
+    <p:sldId xmlns:r="http://schemas.openxmlformats.org/officeDocument/2006/relationships" id="264" r:id="R8a3d748ba38f4a05"/>
+    <p:sldId xmlns:r="http://schemas.openxmlformats.org/officeDocument/2006/relationships" id="265" r:id="Rd575295f38d7477c"/>
+    <p:sldId xmlns:r="http://schemas.openxmlformats.org/officeDocument/2006/relationships" id="266" r:id="Rba5c99702ef04ff3"/>
+    <p:sldId xmlns:r="http://schemas.openxmlformats.org/officeDocument/2006/relationships" id="267" r:id="Rf08b571e200745a3"/>
+    <p:sldId xmlns:r="http://schemas.openxmlformats.org/officeDocument/2006/relationships" id="268" r:id="Rbdac312475f34d5e"/>
+    <p:sldId xmlns:r="http://schemas.openxmlformats.org/officeDocument/2006/relationships" id="269" r:id="R76788e1ae5144623"/>
+    <p:sldId xmlns:r="http://schemas.openxmlformats.org/officeDocument/2006/relationships" id="270" r:id="R3c3a5953fd3446c6"/>
+    <p:sldId xmlns:r="http://schemas.openxmlformats.org/officeDocument/2006/relationships" id="271" r:id="Rb23a4b16e3b64bb6"/>
   </p:sldIdLst>
   <p:sldSz cx="12192000" cy="6858000"/>
   <p:notesSz cx="6858000" cy="9144000"/>
@@ -992,12 +992,12 @@
           <a:lstStyle xmlns:a="http://schemas.openxmlformats.org/drawingml/2006/main"/>
           <a:p xmlns:a="http://schemas.openxmlformats.org/drawingml/2006/main">
             <a:r>
-              <a:t>Project evidence: configs/student.json, docs/methodology.md, sources/assignment.txt.</a:t>
+              <a:t>Project evidence: configs/student.json, docs/methodology.md, docs/GROUP4_VIVA_PLAYBOOK.md.</a:t>
             </a:r>
           </a:p>
           <a:p xmlns:a="http://schemas.openxmlformats.org/drawingml/2006/main">
             <a:r>
-              <a:t>Confirm each student's name, roll number and actual individual contribution before submission. The prompts are preparation questions, not claims about assigned contributions.</a:t>
+              <a:t>Students appear in ascending roll-number order. Speaker assignments designate what to study and present; they do not certify that the students performed the model research, development, experiments or writing. Real contributions are recorded separately in the report after verification.</a:t>
             </a:r>
           </a:p>
         </p:txBody>
@@ -1684,7 +1684,7 @@
           <p:cNvPr id="3" name="Title">
             <a:extLst xmlns:a="http://schemas.openxmlformats.org/drawingml/2006/main">
               <a:ext uri="{FF2B5EF4-FFF2-40B4-BE49-F238E27FC236}">
-                <a16:creationId xmlns:a16="http://schemas.microsoft.com/office/drawing/2014/main" id="{3D703061-7C2B-4049-825C-68A8D5A8C810}"/>
+                <a16:creationId xmlns:a16="http://schemas.microsoft.com/office/drawing/2014/main" id="{B5201DC9-CF6E-4F55-957C-827AAC7CAE47}"/>
               </a:ext>
             </a:extLst>
           </p:cNvPr>
@@ -1913,7 +1913,7 @@
           <p:cNvPr id="2" name="Subtitle">
             <a:extLst xmlns:a="http://schemas.openxmlformats.org/drawingml/2006/main">
               <a:ext uri="{FF2B5EF4-FFF2-40B4-BE49-F238E27FC236}">
-                <a16:creationId xmlns:a16="http://schemas.microsoft.com/office/drawing/2014/main" id="{0FC7325D-9117-4F04-BD5E-F25FCA01300E}"/>
+                <a16:creationId xmlns:a16="http://schemas.microsoft.com/office/drawing/2014/main" id="{5DD808C5-7410-41A9-8BF9-E68665BBBC37}"/>
               </a:ext>
             </a:extLst>
           </p:cNvPr>
@@ -2159,7 +2159,7 @@
           <p:cNvPr id="2" name="Section title">
             <a:extLst xmlns:a="http://schemas.openxmlformats.org/drawingml/2006/main">
               <a:ext uri="{FF2B5EF4-FFF2-40B4-BE49-F238E27FC236}">
-                <a16:creationId xmlns:a16="http://schemas.microsoft.com/office/drawing/2014/main" id="{8C5AD93A-1B67-447C-93D4-697FCCA57D05}"/>
+                <a16:creationId xmlns:a16="http://schemas.microsoft.com/office/drawing/2014/main" id="{BE322D3D-3BBF-447C-801A-662AC9642D27}"/>
               </a:ext>
             </a:extLst>
           </p:cNvPr>
@@ -2405,7 +2405,7 @@
           <p:cNvPr id="3" name="Title">
             <a:extLst xmlns:a="http://schemas.openxmlformats.org/drawingml/2006/main">
               <a:ext uri="{FF2B5EF4-FFF2-40B4-BE49-F238E27FC236}">
-                <a16:creationId xmlns:a16="http://schemas.microsoft.com/office/drawing/2014/main" id="{A111E798-1C80-427F-83C0-078C27D4412F}"/>
+                <a16:creationId xmlns:a16="http://schemas.microsoft.com/office/drawing/2014/main" id="{2D86EEA2-C388-435C-AE81-3CDDE8C02399}"/>
               </a:ext>
             </a:extLst>
           </p:cNvPr>
@@ -2634,7 +2634,7 @@
           <p:cNvPr id="2" name="Body">
             <a:extLst xmlns:a="http://schemas.openxmlformats.org/drawingml/2006/main">
               <a:ext uri="{FF2B5EF4-FFF2-40B4-BE49-F238E27FC236}">
-                <a16:creationId xmlns:a16="http://schemas.microsoft.com/office/drawing/2014/main" id="{8F78BBE3-F3B0-4816-93A5-A1541060C2F8}"/>
+                <a16:creationId xmlns:a16="http://schemas.microsoft.com/office/drawing/2014/main" id="{9EEAF030-027A-4FCA-BD81-11C45DE55289}"/>
               </a:ext>
             </a:extLst>
           </p:cNvPr>
@@ -2880,7 +2880,7 @@
           <p:cNvPr id="4" name="Title">
             <a:extLst xmlns:a="http://schemas.openxmlformats.org/drawingml/2006/main">
               <a:ext uri="{FF2B5EF4-FFF2-40B4-BE49-F238E27FC236}">
-                <a16:creationId xmlns:a16="http://schemas.microsoft.com/office/drawing/2014/main" id="{F3EEAB14-BFFE-4703-A40F-383F509C6544}"/>
+                <a16:creationId xmlns:a16="http://schemas.microsoft.com/office/drawing/2014/main" id="{8CF2ABBD-7D54-4968-B2A6-AB669671C0A6}"/>
               </a:ext>
             </a:extLst>
           </p:cNvPr>
@@ -3109,7 +3109,7 @@
           <p:cNvPr id="2" name="Left column">
             <a:extLst xmlns:a="http://schemas.openxmlformats.org/drawingml/2006/main">
               <a:ext uri="{FF2B5EF4-FFF2-40B4-BE49-F238E27FC236}">
-                <a16:creationId xmlns:a16="http://schemas.microsoft.com/office/drawing/2014/main" id="{BAA998F8-C49F-4E84-8154-006F763CF6F3}"/>
+                <a16:creationId xmlns:a16="http://schemas.microsoft.com/office/drawing/2014/main" id="{91C0441A-9551-44D9-B38D-9C163EF501F8}"/>
               </a:ext>
             </a:extLst>
           </p:cNvPr>
@@ -3338,7 +3338,7 @@
           <p:cNvPr id="3" name="Right column">
             <a:extLst xmlns:a="http://schemas.openxmlformats.org/drawingml/2006/main">
               <a:ext uri="{FF2B5EF4-FFF2-40B4-BE49-F238E27FC236}">
-                <a16:creationId xmlns:a16="http://schemas.microsoft.com/office/drawing/2014/main" id="{ECF067BC-8FFC-4849-A22B-6FD01BEE579B}"/>
+                <a16:creationId xmlns:a16="http://schemas.microsoft.com/office/drawing/2014/main" id="{1D6F7E70-3671-48A8-B68C-4407F3A97D45}"/>
               </a:ext>
             </a:extLst>
           </p:cNvPr>
@@ -3584,7 +3584,7 @@
           <p:cNvPr id="3" name="Title">
             <a:extLst xmlns:a="http://schemas.openxmlformats.org/drawingml/2006/main">
               <a:ext uri="{FF2B5EF4-FFF2-40B4-BE49-F238E27FC236}">
-                <a16:creationId xmlns:a16="http://schemas.microsoft.com/office/drawing/2014/main" id="{6DF3B10D-F8BC-4602-B323-D39138E3972A}"/>
+                <a16:creationId xmlns:a16="http://schemas.microsoft.com/office/drawing/2014/main" id="{79FA5573-62B3-4696-A0E6-3CC35C25EDE2}"/>
               </a:ext>
             </a:extLst>
           </p:cNvPr>
@@ -3813,7 +3813,7 @@
           <p:cNvPr id="2" name="Left column">
             <a:extLst xmlns:a="http://schemas.openxmlformats.org/drawingml/2006/main">
               <a:ext uri="{FF2B5EF4-FFF2-40B4-BE49-F238E27FC236}">
-                <a16:creationId xmlns:a16="http://schemas.microsoft.com/office/drawing/2014/main" id="{96DDEF0A-5E73-4725-BEE6-02657DAABD67}"/>
+                <a16:creationId xmlns:a16="http://schemas.microsoft.com/office/drawing/2014/main" id="{1E6E81A1-1B6B-4BD1-86CA-FC9A6ECF0D10}"/>
               </a:ext>
             </a:extLst>
           </p:cNvPr>
@@ -4080,12 +4080,12 @@
   </p:cSld>
   <p:clrMap bg1="lt1" tx1="dk1" bg2="lt2" tx2="dk2" accent1="accent1" accent2="accent2" accent3="accent3" accent4="accent4" accent5="accent5" accent6="accent6" hlink="hlink" folHlink="folHlink"/>
   <p:sldLayoutIdLst>
-    <p:sldLayoutId xmlns:r="http://schemas.openxmlformats.org/officeDocument/2006/relationships" id="2147483649" r:id="Rf274dc84c0464b77"/>
-    <p:sldLayoutId xmlns:r="http://schemas.openxmlformats.org/officeDocument/2006/relationships" id="2147483650" r:id="R491c5b19500041c0"/>
-    <p:sldLayoutId xmlns:r="http://schemas.openxmlformats.org/officeDocument/2006/relationships" id="2147483651" r:id="R8f1d5ef899914354"/>
-    <p:sldLayoutId xmlns:r="http://schemas.openxmlformats.org/officeDocument/2006/relationships" id="2147483652" r:id="R6a55367be9114e41"/>
-    <p:sldLayoutId xmlns:r="http://schemas.openxmlformats.org/officeDocument/2006/relationships" id="2147483653" r:id="R2708cdc670614f98"/>
-    <p:sldLayoutId xmlns:r="http://schemas.openxmlformats.org/officeDocument/2006/relationships" id="2147483654" r:id="R87793a6932244452"/>
+    <p:sldLayoutId xmlns:r="http://schemas.openxmlformats.org/officeDocument/2006/relationships" id="2147483649" r:id="R8896042182b9426c"/>
+    <p:sldLayoutId xmlns:r="http://schemas.openxmlformats.org/officeDocument/2006/relationships" id="2147483650" r:id="Red959ee8ab4b4ccc"/>
+    <p:sldLayoutId xmlns:r="http://schemas.openxmlformats.org/officeDocument/2006/relationships" id="2147483651" r:id="Rdb707d85e8ad4ce1"/>
+    <p:sldLayoutId xmlns:r="http://schemas.openxmlformats.org/officeDocument/2006/relationships" id="2147483652" r:id="R3c784972747a47f2"/>
+    <p:sldLayoutId xmlns:r="http://schemas.openxmlformats.org/officeDocument/2006/relationships" id="2147483653" r:id="Rb4ea49cf968b49ba"/>
+    <p:sldLayoutId xmlns:r="http://schemas.openxmlformats.org/officeDocument/2006/relationships" id="2147483654" r:id="R144f1c45a5144f61"/>
   </p:sldLayoutIdLst>
   <p:txStyles>
     <p:titleStyle>
@@ -5645,7 +5645,7 @@
           <p:cNvPr id="8" name="divider">
             <a:extLst xmlns:a="http://schemas.openxmlformats.org/drawingml/2006/main">
               <a:ext uri="{FF2B5EF4-FFF2-40B4-BE49-F238E27FC236}">
-                <a16:creationId xmlns:a16="http://schemas.microsoft.com/office/drawing/2014/main" id="{6315501D-DDA5-4785-BB32-D32E47072D73}"/>
+                <a16:creationId xmlns:a16="http://schemas.microsoft.com/office/drawing/2014/main" id="{AB0ABE7B-0E42-4F6A-8364-A3255121EBAC}"/>
               </a:ext>
             </a:extLst>
           </p:cNvPr>
@@ -5678,7 +5678,7 @@
           <p:cNvPr id="2" name="cover-kicker">
             <a:extLst xmlns:a="http://schemas.openxmlformats.org/drawingml/2006/main">
               <a:ext uri="{FF2B5EF4-FFF2-40B4-BE49-F238E27FC236}">
-                <a16:creationId xmlns:a16="http://schemas.microsoft.com/office/drawing/2014/main" id="{E1477775-8042-421C-BDAD-F24962478780}"/>
+                <a16:creationId xmlns:a16="http://schemas.microsoft.com/office/drawing/2014/main" id="{E2AB03C1-78A1-4908-8983-2B39D427877B}"/>
               </a:ext>
             </a:extLst>
           </p:cNvPr>
@@ -5837,7 +5837,7 @@
           <p:cNvPr id="3" name="cover-title">
             <a:extLst xmlns:a="http://schemas.openxmlformats.org/drawingml/2006/main">
               <a:ext uri="{FF2B5EF4-FFF2-40B4-BE49-F238E27FC236}">
-                <a16:creationId xmlns:a16="http://schemas.microsoft.com/office/drawing/2014/main" id="{FACCD0F5-A5D8-4222-9193-7572E8D77D42}"/>
+                <a16:creationId xmlns:a16="http://schemas.microsoft.com/office/drawing/2014/main" id="{2D7DAD82-5D52-4AD8-B7ED-275DA6B0103C}"/>
               </a:ext>
             </a:extLst>
           </p:cNvPr>
@@ -5996,7 +5996,7 @@
           <p:cNvPr id="4" name="cover-subtitle">
             <a:extLst xmlns:a="http://schemas.openxmlformats.org/drawingml/2006/main">
               <a:ext uri="{FF2B5EF4-FFF2-40B4-BE49-F238E27FC236}">
-                <a16:creationId xmlns:a16="http://schemas.microsoft.com/office/drawing/2014/main" id="{E1E90544-7A68-416A-8CAF-1E0307056F00}"/>
+                <a16:creationId xmlns:a16="http://schemas.microsoft.com/office/drawing/2014/main" id="{B0FAC0A4-7AA0-42F7-8B48-20A9AFCD6A2A}"/>
               </a:ext>
             </a:extLst>
           </p:cNvPr>
@@ -6155,7 +6155,7 @@
           <p:cNvPr id="5" name="divider">
             <a:extLst xmlns:a="http://schemas.openxmlformats.org/drawingml/2006/main">
               <a:ext uri="{FF2B5EF4-FFF2-40B4-BE49-F238E27FC236}">
-                <a16:creationId xmlns:a16="http://schemas.microsoft.com/office/drawing/2014/main" id="{DA75F2D5-870A-4B5E-818C-8EE00013A937}"/>
+                <a16:creationId xmlns:a16="http://schemas.microsoft.com/office/drawing/2014/main" id="{E175E06D-FDDB-48EF-A92F-462547484877}"/>
               </a:ext>
             </a:extLst>
           </p:cNvPr>
@@ -6188,7 +6188,7 @@
           <p:cNvPr id="6" name="cover-paper">
             <a:extLst xmlns:a="http://schemas.openxmlformats.org/drawingml/2006/main">
               <a:ext uri="{FF2B5EF4-FFF2-40B4-BE49-F238E27FC236}">
-                <a16:creationId xmlns:a16="http://schemas.microsoft.com/office/drawing/2014/main" id="{399C4C9F-59B6-49D6-90AD-4AF029756A7D}"/>
+                <a16:creationId xmlns:a16="http://schemas.microsoft.com/office/drawing/2014/main" id="{85919842-5E98-4462-8E4A-13F3BA14C0AC}"/>
               </a:ext>
             </a:extLst>
           </p:cNvPr>
@@ -6347,7 +6347,7 @@
           <p:cNvPr id="7" name="cover-details">
             <a:extLst xmlns:a="http://schemas.openxmlformats.org/drawingml/2006/main">
               <a:ext uri="{FF2B5EF4-FFF2-40B4-BE49-F238E27FC236}">
-                <a16:creationId xmlns:a16="http://schemas.microsoft.com/office/drawing/2014/main" id="{5E32638B-DD88-469A-8F93-02FDF1C7D158}"/>
+                <a16:creationId xmlns:a16="http://schemas.microsoft.com/office/drawing/2014/main" id="{F9042830-DDC9-42DE-A7DF-F476ECC3CE18}"/>
               </a:ext>
             </a:extLst>
           </p:cNvPr>
@@ -6496,7 +6496,7 @@
                 <a:ea typeface="Arial"/>
                 <a:cs typeface="Arial"/>
               </a:rPr>
-              <a:t>Recommendation Systems  |  [Group number]  |  [Institution]</a:t>
+              <a:t>Recommendation Systems  |  Group 4  |  SVKM's NMIMS MPSTME, Mumbai</a:t>
             </a:r>
           </a:p>
         </p:txBody>
@@ -6504,7 +6504,7 @@
     </p:spTree>
     <p:extLst>
       <p:ext uri="{BB962C8B-B14F-4D97-AF65-F5344CB8AC3E}">
-        <p14:creationId xmlns:p14="http://schemas.microsoft.com/office/powerpoint/2010/main" val="216939747"/>
+        <p14:creationId xmlns:p14="http://schemas.microsoft.com/office/powerpoint/2010/main" val="1749989818"/>
       </p:ext>
     </p:extLst>
   </p:cSld>
@@ -6535,7 +6535,7 @@
           <p:cNvPr id="7" name="slide-title">
             <a:extLst xmlns:a="http://schemas.openxmlformats.org/drawingml/2006/main">
               <a:ext uri="{FF2B5EF4-FFF2-40B4-BE49-F238E27FC236}">
-                <a16:creationId xmlns:a16="http://schemas.microsoft.com/office/drawing/2014/main" id="{E24653E4-703E-40D1-B9E4-F3F527FAFEF8}"/>
+                <a16:creationId xmlns:a16="http://schemas.microsoft.com/office/drawing/2014/main" id="{F549D6F3-DDCA-4811-B277-14BF928713DA}"/>
               </a:ext>
             </a:extLst>
           </p:cNvPr>
@@ -6694,7 +6694,7 @@
           <p:cNvPr id="2" name="divider">
             <a:extLst xmlns:a="http://schemas.openxmlformats.org/drawingml/2006/main">
               <a:ext uri="{FF2B5EF4-FFF2-40B4-BE49-F238E27FC236}">
-                <a16:creationId xmlns:a16="http://schemas.microsoft.com/office/drawing/2014/main" id="{7D88FCA2-1F65-444D-8BE9-136C28416C07}"/>
+                <a16:creationId xmlns:a16="http://schemas.microsoft.com/office/drawing/2014/main" id="{C0AA90EF-20E3-4E82-8A8B-AB8BB71D54D7}"/>
               </a:ext>
             </a:extLst>
           </p:cNvPr>
@@ -6727,7 +6727,7 @@
           <p:cNvPr id="3" name="slide-subtitle">
             <a:extLst xmlns:a="http://schemas.openxmlformats.org/drawingml/2006/main">
               <a:ext uri="{FF2B5EF4-FFF2-40B4-BE49-F238E27FC236}">
-                <a16:creationId xmlns:a16="http://schemas.microsoft.com/office/drawing/2014/main" id="{BB753762-B32B-4F28-B34F-DF3F83C158FB}"/>
+                <a16:creationId xmlns:a16="http://schemas.microsoft.com/office/drawing/2014/main" id="{E38B1703-4B56-4EBA-90C9-BB90AC1CBB39}"/>
               </a:ext>
             </a:extLst>
           </p:cNvPr>
@@ -6886,7 +6886,7 @@
           <p:cNvPr id="4" name="">
             <a:extLst xmlns:a="http://schemas.openxmlformats.org/drawingml/2006/main">
               <a:ext uri="{FF2B5EF4-FFF2-40B4-BE49-F238E27FC236}">
-                <a16:creationId xmlns:a16="http://schemas.microsoft.com/office/drawing/2014/main" id="{7FD67B07-36AE-4C4D-A2A4-882497439556}"/>
+                <a16:creationId xmlns:a16="http://schemas.microsoft.com/office/drawing/2014/main" id="{CB4BE0DC-331B-4A84-A1E6-D494F87F64A8}"/>
               </a:ext>
             </a:extLst>
           </p:cNvPr>
@@ -8252,7 +8252,7 @@
           <p:cNvPr id="5" name="Chart">
             <a:extLst xmlns:a="http://schemas.openxmlformats.org/drawingml/2006/main">
               <a:ext uri="{FF2B5EF4-FFF2-40B4-BE49-F238E27FC236}">
-                <a16:creationId xmlns:a16="http://schemas.microsoft.com/office/drawing/2014/main" id="{A0FF5534-7C7C-417F-9434-7BE238491F3B}"/>
+                <a16:creationId xmlns:a16="http://schemas.microsoft.com/office/drawing/2014/main" id="{C474ED7D-7BE3-480B-88C9-1A038A3C7A84}"/>
               </a:ext>
             </a:extLst>
           </p:cNvPr>
@@ -8265,7 +8265,7 @@
         </p:xfrm>
         <a:graphic xmlns:a="http://schemas.openxmlformats.org/drawingml/2006/main">
           <a:graphicData uri="http://schemas.openxmlformats.org/drawingml/2006/chart">
-            <c:chart xmlns:r="http://schemas.openxmlformats.org/officeDocument/2006/relationships" xmlns:c="http://schemas.openxmlformats.org/drawingml/2006/chart" r:id="Rf60f8f31f03747b9"/>
+            <c:chart xmlns:r="http://schemas.openxmlformats.org/officeDocument/2006/relationships" xmlns:c="http://schemas.openxmlformats.org/drawingml/2006/chart" r:id="R268822e2fdd54783"/>
           </a:graphicData>
         </a:graphic>
       </p:graphicFrame>
@@ -8274,7 +8274,7 @@
           <p:cNvPr id="6" name="results-footnote">
             <a:extLst xmlns:a="http://schemas.openxmlformats.org/drawingml/2006/main">
               <a:ext uri="{FF2B5EF4-FFF2-40B4-BE49-F238E27FC236}">
-                <a16:creationId xmlns:a16="http://schemas.microsoft.com/office/drawing/2014/main" id="{119BCF22-3EB0-473F-BFB3-47957AF01E8A}"/>
+                <a16:creationId xmlns:a16="http://schemas.microsoft.com/office/drawing/2014/main" id="{8C1929CF-A475-4D94-8D73-762707005AA8}"/>
               </a:ext>
             </a:extLst>
           </p:cNvPr>
@@ -8285,7 +8285,7 @@
         </p:nvSpPr>
         <p:spPr>
           <a:xfrm xmlns:a="http://schemas.openxmlformats.org/drawingml/2006/main">
-            <a:off x="609600" y="5753100"/>
+            <a:off x="609600" y="6115050"/>
             <a:ext cx="10896600" cy="533400"/>
           </a:xfrm>
           <a:prstGeom xmlns:a="http://schemas.openxmlformats.org/drawingml/2006/main" prst="rect">
@@ -8431,7 +8431,7 @@
     </p:spTree>
     <p:extLst>
       <p:ext uri="{BB962C8B-B14F-4D97-AF65-F5344CB8AC3E}">
-        <p14:creationId xmlns:p14="http://schemas.microsoft.com/office/powerpoint/2010/main" val="1856296837"/>
+        <p14:creationId xmlns:p14="http://schemas.microsoft.com/office/powerpoint/2010/main" val="1285244999"/>
       </p:ext>
     </p:extLst>
   </p:cSld>
@@ -8462,7 +8462,7 @@
           <p:cNvPr id="7" name="slide-title">
             <a:extLst xmlns:a="http://schemas.openxmlformats.org/drawingml/2006/main">
               <a:ext uri="{FF2B5EF4-FFF2-40B4-BE49-F238E27FC236}">
-                <a16:creationId xmlns:a16="http://schemas.microsoft.com/office/drawing/2014/main" id="{48E12B2D-72F4-4906-9FAC-9E04AD175B27}"/>
+                <a16:creationId xmlns:a16="http://schemas.microsoft.com/office/drawing/2014/main" id="{DB48563E-F904-4F6E-A839-B34F381D7A88}"/>
               </a:ext>
             </a:extLst>
           </p:cNvPr>
@@ -8621,7 +8621,7 @@
           <p:cNvPr id="2" name="divider">
             <a:extLst xmlns:a="http://schemas.openxmlformats.org/drawingml/2006/main">
               <a:ext uri="{FF2B5EF4-FFF2-40B4-BE49-F238E27FC236}">
-                <a16:creationId xmlns:a16="http://schemas.microsoft.com/office/drawing/2014/main" id="{356E920B-86DE-44A5-B5E5-3195E9E85D92}"/>
+                <a16:creationId xmlns:a16="http://schemas.microsoft.com/office/drawing/2014/main" id="{85AA067B-441D-4F40-AD7D-A8EAC3E1DE6A}"/>
               </a:ext>
             </a:extLst>
           </p:cNvPr>
@@ -8654,7 +8654,7 @@
           <p:cNvPr id="3" name="slide-subtitle">
             <a:extLst xmlns:a="http://schemas.openxmlformats.org/drawingml/2006/main">
               <a:ext uri="{FF2B5EF4-FFF2-40B4-BE49-F238E27FC236}">
-                <a16:creationId xmlns:a16="http://schemas.microsoft.com/office/drawing/2014/main" id="{1DDB040F-85BE-4E8A-AD0C-131109ABA22F}"/>
+                <a16:creationId xmlns:a16="http://schemas.microsoft.com/office/drawing/2014/main" id="{DAC14005-D522-43ED-9648-D86AD8A06FCC}"/>
               </a:ext>
             </a:extLst>
           </p:cNvPr>
@@ -8813,7 +8813,7 @@
           <p:cNvPr id="4" name="">
             <a:extLst xmlns:a="http://schemas.openxmlformats.org/drawingml/2006/main">
               <a:ext uri="{FF2B5EF4-FFF2-40B4-BE49-F238E27FC236}">
-                <a16:creationId xmlns:a16="http://schemas.microsoft.com/office/drawing/2014/main" id="{86B84C9B-446E-47B9-9BAD-F7E647972B5D}"/>
+                <a16:creationId xmlns:a16="http://schemas.microsoft.com/office/drawing/2014/main" id="{CD8F228C-49A6-424A-8B2D-21088966E501}"/>
               </a:ext>
             </a:extLst>
           </p:cNvPr>
@@ -9485,7 +9485,7 @@
           <p:cNvPr id="5" name="Chart">
             <a:extLst xmlns:a="http://schemas.openxmlformats.org/drawingml/2006/main">
               <a:ext uri="{FF2B5EF4-FFF2-40B4-BE49-F238E27FC236}">
-                <a16:creationId xmlns:a16="http://schemas.microsoft.com/office/drawing/2014/main" id="{0CD8DDAF-7F2E-46F7-99DB-3B11F9D9D8BC}"/>
+                <a16:creationId xmlns:a16="http://schemas.microsoft.com/office/drawing/2014/main" id="{E7C5C2EB-0E20-41F9-82E9-8CDBDAB648E7}"/>
               </a:ext>
             </a:extLst>
           </p:cNvPr>
@@ -9498,7 +9498,7 @@
         </p:xfrm>
         <a:graphic xmlns:a="http://schemas.openxmlformats.org/drawingml/2006/main">
           <a:graphicData uri="http://schemas.openxmlformats.org/drawingml/2006/chart">
-            <c:chart xmlns:r="http://schemas.openxmlformats.org/officeDocument/2006/relationships" xmlns:c="http://schemas.openxmlformats.org/drawingml/2006/chart" r:id="R6d55108d023b4d49"/>
+            <c:chart xmlns:r="http://schemas.openxmlformats.org/officeDocument/2006/relationships" xmlns:c="http://schemas.openxmlformats.org/drawingml/2006/chart" r:id="Ra75e054d7cdb4997"/>
           </a:graphicData>
         </a:graphic>
       </p:graphicFrame>
@@ -9507,7 +9507,7 @@
           <p:cNvPr id="6" name="ablation-caution">
             <a:extLst xmlns:a="http://schemas.openxmlformats.org/drawingml/2006/main">
               <a:ext uri="{FF2B5EF4-FFF2-40B4-BE49-F238E27FC236}">
-                <a16:creationId xmlns:a16="http://schemas.microsoft.com/office/drawing/2014/main" id="{45DCCB25-1407-46BA-87A2-55742B251915}"/>
+                <a16:creationId xmlns:a16="http://schemas.microsoft.com/office/drawing/2014/main" id="{D4AC41FC-893E-4D63-9879-B79748DAFC97}"/>
               </a:ext>
             </a:extLst>
           </p:cNvPr>
@@ -9664,7 +9664,7 @@
     </p:spTree>
     <p:extLst>
       <p:ext uri="{BB962C8B-B14F-4D97-AF65-F5344CB8AC3E}">
-        <p14:creationId xmlns:p14="http://schemas.microsoft.com/office/powerpoint/2010/main" val="1929325591"/>
+        <p14:creationId xmlns:p14="http://schemas.microsoft.com/office/powerpoint/2010/main" val="830741484"/>
       </p:ext>
     </p:extLst>
   </p:cSld>
@@ -9695,7 +9695,7 @@
           <p:cNvPr id="8" name="slide-title">
             <a:extLst xmlns:a="http://schemas.openxmlformats.org/drawingml/2006/main">
               <a:ext uri="{FF2B5EF4-FFF2-40B4-BE49-F238E27FC236}">
-                <a16:creationId xmlns:a16="http://schemas.microsoft.com/office/drawing/2014/main" id="{C57D4B02-2776-41AC-A350-75D3B36DE8EC}"/>
+                <a16:creationId xmlns:a16="http://schemas.microsoft.com/office/drawing/2014/main" id="{2882D668-81B1-462B-B923-95C73CF7F6A8}"/>
               </a:ext>
             </a:extLst>
           </p:cNvPr>
@@ -9854,7 +9854,7 @@
           <p:cNvPr id="2" name="divider">
             <a:extLst xmlns:a="http://schemas.openxmlformats.org/drawingml/2006/main">
               <a:ext uri="{FF2B5EF4-FFF2-40B4-BE49-F238E27FC236}">
-                <a16:creationId xmlns:a16="http://schemas.microsoft.com/office/drawing/2014/main" id="{3804370E-AB93-4293-BA6D-E715DA0FAED7}"/>
+                <a16:creationId xmlns:a16="http://schemas.microsoft.com/office/drawing/2014/main" id="{A80780A8-83C0-4D26-908D-5B19E3D7DFA9}"/>
               </a:ext>
             </a:extLst>
           </p:cNvPr>
@@ -9887,7 +9887,7 @@
           <p:cNvPr id="3" name="slide-subtitle">
             <a:extLst xmlns:a="http://schemas.openxmlformats.org/drawingml/2006/main">
               <a:ext uri="{FF2B5EF4-FFF2-40B4-BE49-F238E27FC236}">
-                <a16:creationId xmlns:a16="http://schemas.microsoft.com/office/drawing/2014/main" id="{E8D0DC09-93ED-4CC9-9AFF-78A0AD67BDF6}"/>
+                <a16:creationId xmlns:a16="http://schemas.microsoft.com/office/drawing/2014/main" id="{E40BBE81-DD72-4344-A51C-D74C330EC634}"/>
               </a:ext>
             </a:extLst>
           </p:cNvPr>
@@ -10046,7 +10046,7 @@
           <p:cNvPr id="4" name="compute-config">
             <a:extLst xmlns:a="http://schemas.openxmlformats.org/drawingml/2006/main">
               <a:ext uri="{FF2B5EF4-FFF2-40B4-BE49-F238E27FC236}">
-                <a16:creationId xmlns:a16="http://schemas.microsoft.com/office/drawing/2014/main" id="{3DDB8A80-CF41-4D6C-AC20-C49536D30B4F}"/>
+                <a16:creationId xmlns:a16="http://schemas.microsoft.com/office/drawing/2014/main" id="{193B8557-7A47-4F65-9F28-C1A66F6E5F4B}"/>
               </a:ext>
             </a:extLst>
           </p:cNvPr>
@@ -10205,7 +10205,7 @@
           <p:cNvPr id="5" name="">
             <a:extLst xmlns:a="http://schemas.openxmlformats.org/drawingml/2006/main">
               <a:ext uri="{FF2B5EF4-FFF2-40B4-BE49-F238E27FC236}">
-                <a16:creationId xmlns:a16="http://schemas.microsoft.com/office/drawing/2014/main" id="{121EEFEF-C3C1-4C42-BC81-66B42DB591EA}"/>
+                <a16:creationId xmlns:a16="http://schemas.microsoft.com/office/drawing/2014/main" id="{1A3BAA06-6D73-431B-9D95-EDA9725A6950}"/>
               </a:ext>
             </a:extLst>
           </p:cNvPr>
@@ -11243,7 +11243,7 @@
           <p:cNvPr id="6" name="Chart">
             <a:extLst xmlns:a="http://schemas.openxmlformats.org/drawingml/2006/main">
               <a:ext uri="{FF2B5EF4-FFF2-40B4-BE49-F238E27FC236}">
-                <a16:creationId xmlns:a16="http://schemas.microsoft.com/office/drawing/2014/main" id="{E4832E3C-CE8D-4CF6-AB00-77078D74A958}"/>
+                <a16:creationId xmlns:a16="http://schemas.microsoft.com/office/drawing/2014/main" id="{2DC83288-8155-4FB5-B2EB-0EDD4DD6A434}"/>
               </a:ext>
             </a:extLst>
           </p:cNvPr>
@@ -11256,7 +11256,7 @@
         </p:xfrm>
         <a:graphic xmlns:a="http://schemas.openxmlformats.org/drawingml/2006/main">
           <a:graphicData uri="http://schemas.openxmlformats.org/drawingml/2006/chart">
-            <c:chart xmlns:r="http://schemas.openxmlformats.org/officeDocument/2006/relationships" xmlns:c="http://schemas.openxmlformats.org/drawingml/2006/chart" r:id="Raabf8f512b5a40c8"/>
+            <c:chart xmlns:r="http://schemas.openxmlformats.org/officeDocument/2006/relationships" xmlns:c="http://schemas.openxmlformats.org/drawingml/2006/chart" r:id="R154108501ef5486f"/>
           </a:graphicData>
         </a:graphic>
       </p:graphicFrame>
@@ -11265,7 +11265,7 @@
           <p:cNvPr id="7" name="cost-caveat">
             <a:extLst xmlns:a="http://schemas.openxmlformats.org/drawingml/2006/main">
               <a:ext uri="{FF2B5EF4-FFF2-40B4-BE49-F238E27FC236}">
-                <a16:creationId xmlns:a16="http://schemas.microsoft.com/office/drawing/2014/main" id="{CF42D532-0960-4042-8219-9FE007F90078}"/>
+                <a16:creationId xmlns:a16="http://schemas.microsoft.com/office/drawing/2014/main" id="{A41B806E-14E9-4D79-A4A0-7B7D8980FEBE}"/>
               </a:ext>
             </a:extLst>
           </p:cNvPr>
@@ -11422,7 +11422,7 @@
     </p:spTree>
     <p:extLst>
       <p:ext uri="{BB962C8B-B14F-4D97-AF65-F5344CB8AC3E}">
-        <p14:creationId xmlns:p14="http://schemas.microsoft.com/office/powerpoint/2010/main" val="1701374449"/>
+        <p14:creationId xmlns:p14="http://schemas.microsoft.com/office/powerpoint/2010/main" val="1010185601"/>
       </p:ext>
     </p:extLst>
   </p:cSld>
@@ -11453,7 +11453,7 @@
           <p:cNvPr id="6" name="slide-title">
             <a:extLst xmlns:a="http://schemas.openxmlformats.org/drawingml/2006/main">
               <a:ext uri="{FF2B5EF4-FFF2-40B4-BE49-F238E27FC236}">
-                <a16:creationId xmlns:a16="http://schemas.microsoft.com/office/drawing/2014/main" id="{6946145B-C1D0-4D9E-9E5B-E6BADB35370B}"/>
+                <a16:creationId xmlns:a16="http://schemas.microsoft.com/office/drawing/2014/main" id="{20CDFAFD-A9C8-481B-A712-4830DB0976A3}"/>
               </a:ext>
             </a:extLst>
           </p:cNvPr>
@@ -11612,7 +11612,7 @@
           <p:cNvPr id="2" name="divider">
             <a:extLst xmlns:a="http://schemas.openxmlformats.org/drawingml/2006/main">
               <a:ext uri="{FF2B5EF4-FFF2-40B4-BE49-F238E27FC236}">
-                <a16:creationId xmlns:a16="http://schemas.microsoft.com/office/drawing/2014/main" id="{ECF8C4CC-79EC-4004-B15E-F2D75D11589C}"/>
+                <a16:creationId xmlns:a16="http://schemas.microsoft.com/office/drawing/2014/main" id="{5E99EA22-5977-4379-9C6E-D52815018582}"/>
               </a:ext>
             </a:extLst>
           </p:cNvPr>
@@ -11645,7 +11645,7 @@
           <p:cNvPr id="3" name="slide-subtitle">
             <a:extLst xmlns:a="http://schemas.openxmlformats.org/drawingml/2006/main">
               <a:ext uri="{FF2B5EF4-FFF2-40B4-BE49-F238E27FC236}">
-                <a16:creationId xmlns:a16="http://schemas.microsoft.com/office/drawing/2014/main" id="{3BDFFED4-2C69-44F2-B1DD-9BC81B326B62}"/>
+                <a16:creationId xmlns:a16="http://schemas.microsoft.com/office/drawing/2014/main" id="{0E8A4AE9-B14D-4D21-8489-793FBAAAA50F}"/>
               </a:ext>
             </a:extLst>
           </p:cNvPr>
@@ -11804,7 +11804,7 @@
           <p:cNvPr id="4" name="">
             <a:extLst xmlns:a="http://schemas.openxmlformats.org/drawingml/2006/main">
               <a:ext uri="{FF2B5EF4-FFF2-40B4-BE49-F238E27FC236}">
-                <a16:creationId xmlns:a16="http://schemas.microsoft.com/office/drawing/2014/main" id="{9581ED09-15BF-4C6B-82FF-DD66035DCAE2}"/>
+                <a16:creationId xmlns:a16="http://schemas.microsoft.com/office/drawing/2014/main" id="{C3CFF203-4172-4567-BD33-252065ECACB0}"/>
               </a:ext>
             </a:extLst>
           </p:cNvPr>
@@ -12476,7 +12476,7 @@
           <p:cNvPr id="5" name="paper-comparison-caveat">
             <a:extLst xmlns:a="http://schemas.openxmlformats.org/drawingml/2006/main">
               <a:ext uri="{FF2B5EF4-FFF2-40B4-BE49-F238E27FC236}">
-                <a16:creationId xmlns:a16="http://schemas.microsoft.com/office/drawing/2014/main" id="{B4705F44-D8FD-4793-9D85-8C190AD64069}"/>
+                <a16:creationId xmlns:a16="http://schemas.microsoft.com/office/drawing/2014/main" id="{2382C62F-6B28-43FE-90ED-2AFF00CE946E}"/>
               </a:ext>
             </a:extLst>
           </p:cNvPr>
@@ -12633,7 +12633,7 @@
     </p:spTree>
     <p:extLst>
       <p:ext uri="{BB962C8B-B14F-4D97-AF65-F5344CB8AC3E}">
-        <p14:creationId xmlns:p14="http://schemas.microsoft.com/office/powerpoint/2010/main" val="1111108778"/>
+        <p14:creationId xmlns:p14="http://schemas.microsoft.com/office/powerpoint/2010/main" val="2057056237"/>
       </p:ext>
     </p:extLst>
   </p:cSld>
@@ -12664,7 +12664,7 @@
           <p:cNvPr id="12" name="slide-title">
             <a:extLst xmlns:a="http://schemas.openxmlformats.org/drawingml/2006/main">
               <a:ext uri="{FF2B5EF4-FFF2-40B4-BE49-F238E27FC236}">
-                <a16:creationId xmlns:a16="http://schemas.microsoft.com/office/drawing/2014/main" id="{AFE981FD-5342-4D64-AC41-708984479DFC}"/>
+                <a16:creationId xmlns:a16="http://schemas.microsoft.com/office/drawing/2014/main" id="{26F0B37B-DBEA-4426-A6B1-7D2A4F252089}"/>
               </a:ext>
             </a:extLst>
           </p:cNvPr>
@@ -12823,7 +12823,7 @@
           <p:cNvPr id="2" name="divider">
             <a:extLst xmlns:a="http://schemas.openxmlformats.org/drawingml/2006/main">
               <a:ext uri="{FF2B5EF4-FFF2-40B4-BE49-F238E27FC236}">
-                <a16:creationId xmlns:a16="http://schemas.microsoft.com/office/drawing/2014/main" id="{ABFB4E2E-F524-40C4-9F25-60F194B2C45C}"/>
+                <a16:creationId xmlns:a16="http://schemas.microsoft.com/office/drawing/2014/main" id="{11548C4E-3281-4184-8890-B383F02F48C6}"/>
               </a:ext>
             </a:extLst>
           </p:cNvPr>
@@ -12856,7 +12856,7 @@
           <p:cNvPr id="3" name="slide-subtitle">
             <a:extLst xmlns:a="http://schemas.openxmlformats.org/drawingml/2006/main">
               <a:ext uri="{FF2B5EF4-FFF2-40B4-BE49-F238E27FC236}">
-                <a16:creationId xmlns:a16="http://schemas.microsoft.com/office/drawing/2014/main" id="{E92FF59A-A493-4EC5-ABCA-E306EC89A9B7}"/>
+                <a16:creationId xmlns:a16="http://schemas.microsoft.com/office/drawing/2014/main" id="{973E04D2-D67F-4605-9B06-252BFE70BC62}"/>
               </a:ext>
             </a:extLst>
           </p:cNvPr>
@@ -13015,7 +13015,7 @@
           <p:cNvPr id="4" name="divider">
             <a:extLst xmlns:a="http://schemas.openxmlformats.org/drawingml/2006/main">
               <a:ext uri="{FF2B5EF4-FFF2-40B4-BE49-F238E27FC236}">
-                <a16:creationId xmlns:a16="http://schemas.microsoft.com/office/drawing/2014/main" id="{493435BE-F409-4C4B-9CEB-6E550415A714}"/>
+                <a16:creationId xmlns:a16="http://schemas.microsoft.com/office/drawing/2014/main" id="{2E75D741-CF71-40C1-A81C-426B41594665}"/>
               </a:ext>
             </a:extLst>
           </p:cNvPr>
@@ -13048,7 +13048,7 @@
           <p:cNvPr id="5" name="column-title">
             <a:extLst xmlns:a="http://schemas.openxmlformats.org/drawingml/2006/main">
               <a:ext uri="{FF2B5EF4-FFF2-40B4-BE49-F238E27FC236}">
-                <a16:creationId xmlns:a16="http://schemas.microsoft.com/office/drawing/2014/main" id="{E1B16892-6E4C-4276-85E9-607DD49E1A9F}"/>
+                <a16:creationId xmlns:a16="http://schemas.microsoft.com/office/drawing/2014/main" id="{5334F204-9749-4611-A71A-3CCAFCFF61CE}"/>
               </a:ext>
             </a:extLst>
           </p:cNvPr>
@@ -13207,7 +13207,7 @@
           <p:cNvPr id="6" name="column-copy">
             <a:extLst xmlns:a="http://schemas.openxmlformats.org/drawingml/2006/main">
               <a:ext uri="{FF2B5EF4-FFF2-40B4-BE49-F238E27FC236}">
-                <a16:creationId xmlns:a16="http://schemas.microsoft.com/office/drawing/2014/main" id="{B2A96B91-8FA2-4692-BC22-7CA57F52C4DC}"/>
+                <a16:creationId xmlns:a16="http://schemas.microsoft.com/office/drawing/2014/main" id="{48B76F9D-64E3-4F14-999C-88051E7B0C0D}"/>
               </a:ext>
             </a:extLst>
           </p:cNvPr>
@@ -13402,7 +13402,7 @@
           <p:cNvPr id="7" name="divider">
             <a:extLst xmlns:a="http://schemas.openxmlformats.org/drawingml/2006/main">
               <a:ext uri="{FF2B5EF4-FFF2-40B4-BE49-F238E27FC236}">
-                <a16:creationId xmlns:a16="http://schemas.microsoft.com/office/drawing/2014/main" id="{AFFC67C5-A3C4-4CBA-921E-B9DCF4C0AC0A}"/>
+                <a16:creationId xmlns:a16="http://schemas.microsoft.com/office/drawing/2014/main" id="{3670DC7F-C7E1-43EF-B490-B91A464529B2}"/>
               </a:ext>
             </a:extLst>
           </p:cNvPr>
@@ -13435,7 +13435,7 @@
           <p:cNvPr id="8" name="column-title">
             <a:extLst xmlns:a="http://schemas.openxmlformats.org/drawingml/2006/main">
               <a:ext uri="{FF2B5EF4-FFF2-40B4-BE49-F238E27FC236}">
-                <a16:creationId xmlns:a16="http://schemas.microsoft.com/office/drawing/2014/main" id="{DA08F986-7DF8-4C21-AFA4-94199D16BA56}"/>
+                <a16:creationId xmlns:a16="http://schemas.microsoft.com/office/drawing/2014/main" id="{0061E7CA-66AD-4D2F-AC1C-446AC20E311B}"/>
               </a:ext>
             </a:extLst>
           </p:cNvPr>
@@ -13594,7 +13594,7 @@
           <p:cNvPr id="9" name="column-copy">
             <a:extLst xmlns:a="http://schemas.openxmlformats.org/drawingml/2006/main">
               <a:ext uri="{FF2B5EF4-FFF2-40B4-BE49-F238E27FC236}">
-                <a16:creationId xmlns:a16="http://schemas.microsoft.com/office/drawing/2014/main" id="{A2B7B2DB-D5C5-4ACB-92A7-559EA82B2015}"/>
+                <a16:creationId xmlns:a16="http://schemas.microsoft.com/office/drawing/2014/main" id="{8204ABE9-ABED-4C53-A37E-375CD0A3069D}"/>
               </a:ext>
             </a:extLst>
           </p:cNvPr>
@@ -13789,7 +13789,7 @@
           <p:cNvPr id="10" name="divider">
             <a:extLst xmlns:a="http://schemas.openxmlformats.org/drawingml/2006/main">
               <a:ext uri="{FF2B5EF4-FFF2-40B4-BE49-F238E27FC236}">
-                <a16:creationId xmlns:a16="http://schemas.microsoft.com/office/drawing/2014/main" id="{B2FF6D5E-C875-4E81-A4B9-201FA8A8506C}"/>
+                <a16:creationId xmlns:a16="http://schemas.microsoft.com/office/drawing/2014/main" id="{4759BE68-1B8D-46C2-94FD-FFCF42ADD10E}"/>
               </a:ext>
             </a:extLst>
           </p:cNvPr>
@@ -13822,7 +13822,7 @@
           <p:cNvPr id="11" name="result-interpretation-limit">
             <a:extLst xmlns:a="http://schemas.openxmlformats.org/drawingml/2006/main">
               <a:ext uri="{FF2B5EF4-FFF2-40B4-BE49-F238E27FC236}">
-                <a16:creationId xmlns:a16="http://schemas.microsoft.com/office/drawing/2014/main" id="{86862140-8A97-4F3F-A236-4EB7FA417241}"/>
+                <a16:creationId xmlns:a16="http://schemas.microsoft.com/office/drawing/2014/main" id="{F8772F5F-0AA4-4CE0-8DBE-CA722A28653D}"/>
               </a:ext>
             </a:extLst>
           </p:cNvPr>
@@ -13979,7 +13979,7 @@
     </p:spTree>
     <p:extLst>
       <p:ext uri="{BB962C8B-B14F-4D97-AF65-F5344CB8AC3E}">
-        <p14:creationId xmlns:p14="http://schemas.microsoft.com/office/powerpoint/2010/main" val="1643795852"/>
+        <p14:creationId xmlns:p14="http://schemas.microsoft.com/office/powerpoint/2010/main" val="587778762"/>
       </p:ext>
     </p:extLst>
   </p:cSld>
@@ -14010,7 +14010,7 @@
           <p:cNvPr id="8" name="slide-title">
             <a:extLst xmlns:a="http://schemas.openxmlformats.org/drawingml/2006/main">
               <a:ext uri="{FF2B5EF4-FFF2-40B4-BE49-F238E27FC236}">
-                <a16:creationId xmlns:a16="http://schemas.microsoft.com/office/drawing/2014/main" id="{433D5BD2-E53C-4276-B9F2-95AAE1D7E153}"/>
+                <a16:creationId xmlns:a16="http://schemas.microsoft.com/office/drawing/2014/main" id="{1AB2792C-F33C-4A70-9267-2632B5A03612}"/>
               </a:ext>
             </a:extLst>
           </p:cNvPr>
@@ -14169,7 +14169,7 @@
           <p:cNvPr id="2" name="divider">
             <a:extLst xmlns:a="http://schemas.openxmlformats.org/drawingml/2006/main">
               <a:ext uri="{FF2B5EF4-FFF2-40B4-BE49-F238E27FC236}">
-                <a16:creationId xmlns:a16="http://schemas.microsoft.com/office/drawing/2014/main" id="{7F3B17D0-BEE4-41AE-973A-99AABC072F8C}"/>
+                <a16:creationId xmlns:a16="http://schemas.microsoft.com/office/drawing/2014/main" id="{F6EE969C-1742-472C-ABF5-BC2BC46553AA}"/>
               </a:ext>
             </a:extLst>
           </p:cNvPr>
@@ -14202,7 +14202,7 @@
           <p:cNvPr id="3" name="slide-subtitle">
             <a:extLst xmlns:a="http://schemas.openxmlformats.org/drawingml/2006/main">
               <a:ext uri="{FF2B5EF4-FFF2-40B4-BE49-F238E27FC236}">
-                <a16:creationId xmlns:a16="http://schemas.microsoft.com/office/drawing/2014/main" id="{934472C3-3A39-457A-B74D-0F565E45874B}"/>
+                <a16:creationId xmlns:a16="http://schemas.microsoft.com/office/drawing/2014/main" id="{ABD4FFBD-6B10-4BD1-B9C9-FE8DD0E87C0C}"/>
               </a:ext>
             </a:extLst>
           </p:cNvPr>
@@ -14361,7 +14361,7 @@
           <p:cNvPr id="4" name="limitations-list">
             <a:extLst xmlns:a="http://schemas.openxmlformats.org/drawingml/2006/main">
               <a:ext uri="{FF2B5EF4-FFF2-40B4-BE49-F238E27FC236}">
-                <a16:creationId xmlns:a16="http://schemas.microsoft.com/office/drawing/2014/main" id="{53FF2E32-D1F1-4956-9525-B27C656EBFA9}"/>
+                <a16:creationId xmlns:a16="http://schemas.microsoft.com/office/drawing/2014/main" id="{D8E824AD-4BF6-40D0-BD3A-E3E1A17AE7F3}"/>
               </a:ext>
             </a:extLst>
           </p:cNvPr>
@@ -14632,7 +14632,7 @@
           <p:cNvPr id="5" name="divider">
             <a:extLst xmlns:a="http://schemas.openxmlformats.org/drawingml/2006/main">
               <a:ext uri="{FF2B5EF4-FFF2-40B4-BE49-F238E27FC236}">
-                <a16:creationId xmlns:a16="http://schemas.microsoft.com/office/drawing/2014/main" id="{28DFA2E7-BBFC-4732-898D-A60393208D4C}"/>
+                <a16:creationId xmlns:a16="http://schemas.microsoft.com/office/drawing/2014/main" id="{E23C4CCF-ABC6-42D2-8B17-7147886ADC8A}"/>
               </a:ext>
             </a:extLst>
           </p:cNvPr>
@@ -14665,7 +14665,7 @@
           <p:cNvPr id="6" name="improvement-heading">
             <a:extLst xmlns:a="http://schemas.openxmlformats.org/drawingml/2006/main">
               <a:ext uri="{FF2B5EF4-FFF2-40B4-BE49-F238E27FC236}">
-                <a16:creationId xmlns:a16="http://schemas.microsoft.com/office/drawing/2014/main" id="{2C92C919-30C2-472A-9415-E42C102227E8}"/>
+                <a16:creationId xmlns:a16="http://schemas.microsoft.com/office/drawing/2014/main" id="{3698BF72-292E-4669-8B2E-135DF9A5F547}"/>
               </a:ext>
             </a:extLst>
           </p:cNvPr>
@@ -14824,7 +14824,7 @@
           <p:cNvPr id="7" name="improvement-proposal">
             <a:extLst xmlns:a="http://schemas.openxmlformats.org/drawingml/2006/main">
               <a:ext uri="{FF2B5EF4-FFF2-40B4-BE49-F238E27FC236}">
-                <a16:creationId xmlns:a16="http://schemas.microsoft.com/office/drawing/2014/main" id="{F370C15B-4EE6-4294-8767-F55E0C6B3514}"/>
+                <a16:creationId xmlns:a16="http://schemas.microsoft.com/office/drawing/2014/main" id="{A13FFEA4-E514-4B36-9206-8727EA78BEBD}"/>
               </a:ext>
             </a:extLst>
           </p:cNvPr>
@@ -14981,7 +14981,7 @@
     </p:spTree>
     <p:extLst>
       <p:ext uri="{BB962C8B-B14F-4D97-AF65-F5344CB8AC3E}">
-        <p14:creationId xmlns:p14="http://schemas.microsoft.com/office/powerpoint/2010/main" val="594924545"/>
+        <p14:creationId xmlns:p14="http://schemas.microsoft.com/office/powerpoint/2010/main" val="754802154"/>
       </p:ext>
     </p:extLst>
   </p:cSld>
@@ -15012,7 +15012,7 @@
           <p:cNvPr id="7" name="slide-title">
             <a:extLst xmlns:a="http://schemas.openxmlformats.org/drawingml/2006/main">
               <a:ext uri="{FF2B5EF4-FFF2-40B4-BE49-F238E27FC236}">
-                <a16:creationId xmlns:a16="http://schemas.microsoft.com/office/drawing/2014/main" id="{F524E603-0E28-4B73-BEA1-509F46439DFC}"/>
+                <a16:creationId xmlns:a16="http://schemas.microsoft.com/office/drawing/2014/main" id="{59AF576B-56CE-455E-B498-2A60DF9D036F}"/>
               </a:ext>
             </a:extLst>
           </p:cNvPr>
@@ -15161,7 +15161,7 @@
                 <a:ea typeface="Arial"/>
                 <a:cs typeface="Arial"/>
               </a:rPr>
-              <a:t>Project team and viva</a:t>
+              <a:t>Group 4 presentation and viva</a:t>
             </a:r>
           </a:p>
         </p:txBody>
@@ -15171,7 +15171,7 @@
           <p:cNvPr id="2" name="divider">
             <a:extLst xmlns:a="http://schemas.openxmlformats.org/drawingml/2006/main">
               <a:ext uri="{FF2B5EF4-FFF2-40B4-BE49-F238E27FC236}">
-                <a16:creationId xmlns:a16="http://schemas.microsoft.com/office/drawing/2014/main" id="{F7073034-F313-493D-ADFD-AE1651480916}"/>
+                <a16:creationId xmlns:a16="http://schemas.microsoft.com/office/drawing/2014/main" id="{47F75D50-29F4-401A-B588-996DB9F79671}"/>
               </a:ext>
             </a:extLst>
           </p:cNvPr>
@@ -15204,7 +15204,7 @@
           <p:cNvPr id="3" name="slide-subtitle">
             <a:extLst xmlns:a="http://schemas.openxmlformats.org/drawingml/2006/main">
               <a:ext uri="{FF2B5EF4-FFF2-40B4-BE49-F238E27FC236}">
-                <a16:creationId xmlns:a16="http://schemas.microsoft.com/office/drawing/2014/main" id="{D631202D-9935-4113-A813-14BC202B52CF}"/>
+                <a16:creationId xmlns:a16="http://schemas.microsoft.com/office/drawing/2014/main" id="{3C0DFB8E-9517-42F0-A10D-BA85C32C374A}"/>
               </a:ext>
             </a:extLst>
           </p:cNvPr>
@@ -15353,7 +15353,7 @@
                 <a:ea typeface="Arial"/>
                 <a:cs typeface="Arial"/>
               </a:rPr>
-              <a:t>Names and contributions stay editable until the team verifies them</a:t>
+              <a:t>Assigned speaking roles, not claims of completed individual work</a:t>
             </a:r>
           </a:p>
         </p:txBody>
@@ -15363,7 +15363,7 @@
           <p:cNvPr id="4" name="">
             <a:extLst xmlns:a="http://schemas.openxmlformats.org/drawingml/2006/main">
               <a:ext uri="{FF2B5EF4-FFF2-40B4-BE49-F238E27FC236}">
-                <a16:creationId xmlns:a16="http://schemas.microsoft.com/office/drawing/2014/main" id="{9E149964-EF1E-4330-84A5-76F2F7B86C2C}"/>
+                <a16:creationId xmlns:a16="http://schemas.microsoft.com/office/drawing/2014/main" id="{2E594E4E-571F-4A2A-BF9A-E38A379CBB8A}"/>
               </a:ext>
             </a:extLst>
           </p:cNvPr>
@@ -15372,7 +15372,7 @@
         </p:nvGraphicFramePr>
         <p:xfrm>
           <a:off xmlns:a="http://schemas.openxmlformats.org/drawingml/2006/main" x="609600" y="1847850"/>
-          <a:ext xmlns:a="http://schemas.openxmlformats.org/drawingml/2006/main" cx="10972800" cy="1943100"/>
+          <a:ext xmlns:a="http://schemas.openxmlformats.org/drawingml/2006/main" cx="10972800" cy="2095500"/>
         </p:xfrm>
         <a:graphic xmlns:a="http://schemas.openxmlformats.org/drawingml/2006/main">
           <a:graphicData uri="http://schemas.openxmlformats.org/drawingml/2006/table">
@@ -15383,7 +15383,7 @@
                 <a:gridCol w="2095500"/>
                 <a:gridCol w="6019800"/>
               </a:tblGrid>
-              <a:tr h="647700">
+              <a:tr h="419100">
                 <a:tc>
                   <a:txBody>
                     <a:bodyPr wrap="square" lIns="76200" tIns="47625" rIns="57150" bIns="47625">
@@ -15393,7 +15393,7 @@
                     <a:p>
                       <a:pPr algn="l"/>
                       <a:r>
-                        <a:rPr sz="1350" b="1">
+                        <a:rPr sz="1200" b="1">
                           <a:solidFill>
                             <a:srgbClr val="FFFFFF"/>
                           </a:solidFill>
@@ -15444,7 +15444,7 @@
                     <a:p>
                       <a:pPr algn="ctr"/>
                       <a:r>
-                        <a:rPr sz="1350" b="1">
+                        <a:rPr sz="1200" b="1">
                           <a:solidFill>
                             <a:srgbClr val="FFFFFF"/>
                           </a:solidFill>
@@ -15489,7 +15489,7 @@
                     <a:p>
                       <a:pPr algn="ctr"/>
                       <a:r>
-                        <a:rPr sz="1350" b="1">
+                        <a:rPr sz="1200" b="1">
                           <a:solidFill>
                             <a:srgbClr val="FFFFFF"/>
                           </a:solidFill>
@@ -15497,7 +15497,7 @@
                           <a:ea typeface="Arial"/>
                           <a:cs typeface="Arial"/>
                         </a:rPr>
-                        <a:t>Individual contribution</a:t>
+                        <a:t>Assigned slides and topic</a:t>
                       </a:r>
                     </a:p>
                   </a:txBody>
@@ -15526,7 +15526,7 @@
                   </a:tcPr>
                 </a:tc>
               </a:tr>
-              <a:tr h="647700">
+              <a:tr h="419100">
                 <a:tc>
                   <a:txBody>
                     <a:bodyPr wrap="square" lIns="76200" tIns="47625" rIns="57150" bIns="47625">
@@ -15536,7 +15536,7 @@
                     <a:p>
                       <a:pPr algn="l"/>
                       <a:r>
-                        <a:rPr sz="1350" b="1">
+                        <a:rPr sz="1200" b="1">
                           <a:solidFill>
                             <a:srgbClr val="293A45"/>
                           </a:solidFill>
@@ -15544,7 +15544,7 @@
                           <a:ea typeface="Arial"/>
                           <a:cs typeface="Arial"/>
                         </a:rPr>
-                        <a:t>[Student name]</a:t>
+                        <a:t>Dhruva Ambhaikar</a:t>
                       </a:r>
                     </a:p>
                   </a:txBody>
@@ -15581,7 +15581,7 @@
                     <a:p>
                       <a:pPr algn="ctr"/>
                       <a:r>
-                        <a:rPr sz="1350" b="0">
+                        <a:rPr sz="1200" b="0">
                           <a:solidFill>
                             <a:srgbClr val="293A45"/>
                           </a:solidFill>
@@ -15589,7 +15589,7 @@
                           <a:ea typeface="Arial"/>
                           <a:cs typeface="Arial"/>
                         </a:rPr>
-                        <a:t>[Roll number]</a:t>
+                        <a:t>I002</a:t>
                       </a:r>
                     </a:p>
                   </a:txBody>
@@ -15620,7 +15620,7 @@
                     <a:p>
                       <a:pPr algn="ctr"/>
                       <a:r>
-                        <a:rPr sz="1350" b="0">
+                        <a:rPr sz="1200" b="0">
                           <a:solidFill>
                             <a:srgbClr val="293A45"/>
                           </a:solidFill>
@@ -15628,7 +15628,7 @@
                           <a:ea typeface="Arial"/>
                           <a:cs typeface="Arial"/>
                         </a:rPr>
-                        <a:t>[Describe actual individual contribution]</a:t>
+                        <a:t>Slides 1-3: Problem and research gap</a:t>
                       </a:r>
                     </a:p>
                   </a:txBody>
@@ -15651,7 +15651,7 @@
                   </a:tcPr>
                 </a:tc>
               </a:tr>
-              <a:tr h="647700">
+              <a:tr h="419100">
                 <a:tc>
                   <a:txBody>
                     <a:bodyPr wrap="square" lIns="76200" tIns="47625" rIns="57150" bIns="47625">
@@ -15661,7 +15661,7 @@
                     <a:p>
                       <a:pPr algn="l"/>
                       <a:r>
-                        <a:rPr sz="1350" b="1">
+                        <a:rPr sz="1200" b="1">
                           <a:solidFill>
                             <a:srgbClr val="293A45"/>
                           </a:solidFill>
@@ -15669,7 +15669,7 @@
                           <a:ea typeface="Arial"/>
                           <a:cs typeface="Arial"/>
                         </a:rPr>
-                        <a:t>[Student name]</a:t>
+                        <a:t>Viraj Choudhary</a:t>
                       </a:r>
                     </a:p>
                   </a:txBody>
@@ -15706,7 +15706,7 @@
                     <a:p>
                       <a:pPr algn="ctr"/>
                       <a:r>
-                        <a:rPr sz="1350" b="0">
+                        <a:rPr sz="1200" b="0">
                           <a:solidFill>
                             <a:srgbClr val="293A45"/>
                           </a:solidFill>
@@ -15714,7 +15714,7 @@
                           <a:ea typeface="Arial"/>
                           <a:cs typeface="Arial"/>
                         </a:rPr>
-                        <a:t>[Roll number]</a:t>
+                        <a:t>I012</a:t>
                       </a:r>
                     </a:p>
                   </a:txBody>
@@ -15745,7 +15745,7 @@
                     <a:p>
                       <a:pPr algn="ctr"/>
                       <a:r>
-                        <a:rPr sz="1350" b="0">
+                        <a:rPr sz="1200" b="0">
                           <a:solidFill>
                             <a:srgbClr val="293A45"/>
                           </a:solidFill>
@@ -15753,7 +15753,257 @@
                           <a:ea typeface="Arial"/>
                           <a:cs typeface="Arial"/>
                         </a:rPr>
-                        <a:t>[Describe actual individual contribution]</a:t>
+                        <a:t>Slides 4-7: Architecture and implementation</a:t>
+                      </a:r>
+                    </a:p>
+                  </a:txBody>
+                  <a:tcPr marL="91440" marR="91440" marT="45720" marB="45720" anchor="ctr">
+                    <a:lnR w="9525">
+                      <a:solidFill>
+                        <a:srgbClr val="D5DEE3"/>
+                      </a:solidFill>
+                      <a:prstDash val="solid"/>
+                    </a:lnR>
+                    <a:lnB w="9525">
+                      <a:solidFill>
+                        <a:srgbClr val="D5DEE3"/>
+                      </a:solidFill>
+                      <a:prstDash val="solid"/>
+                    </a:lnB>
+                    <a:solidFill>
+                      <a:srgbClr val="F3F6F7"/>
+                    </a:solidFill>
+                  </a:tcPr>
+                </a:tc>
+              </a:tr>
+              <a:tr h="419100">
+                <a:tc>
+                  <a:txBody>
+                    <a:bodyPr wrap="square" lIns="76200" tIns="47625" rIns="57150" bIns="47625">
+                      <a:normAutofit/>
+                    </a:bodyPr>
+                    <a:lstStyle/>
+                    <a:p>
+                      <a:pPr algn="l"/>
+                      <a:r>
+                        <a:rPr sz="1200" b="1">
+                          <a:solidFill>
+                            <a:srgbClr val="293A45"/>
+                          </a:solidFill>
+                          <a:latin typeface="Arial"/>
+                          <a:ea typeface="Arial"/>
+                          <a:cs typeface="Arial"/>
+                        </a:rPr>
+                        <a:t>Rusheel Sharma</a:t>
+                      </a:r>
+                    </a:p>
+                  </a:txBody>
+                  <a:tcPr marL="91440" marR="91440" marT="45720" marB="45720" anchor="ctr">
+                    <a:lnL w="9525">
+                      <a:solidFill>
+                        <a:srgbClr val="D5DEE3"/>
+                      </a:solidFill>
+                      <a:prstDash val="solid"/>
+                    </a:lnL>
+                    <a:lnR w="9525">
+                      <a:solidFill>
+                        <a:srgbClr val="D5DEE3"/>
+                      </a:solidFill>
+                      <a:prstDash val="solid"/>
+                    </a:lnR>
+                    <a:lnB w="9525">
+                      <a:solidFill>
+                        <a:srgbClr val="D5DEE3"/>
+                      </a:solidFill>
+                      <a:prstDash val="solid"/>
+                    </a:lnB>
+                    <a:solidFill>
+                      <a:srgbClr val="FFFFFF"/>
+                    </a:solidFill>
+                  </a:tcPr>
+                </a:tc>
+                <a:tc>
+                  <a:txBody>
+                    <a:bodyPr wrap="square" lIns="76200" tIns="47625" rIns="57150" bIns="47625">
+                      <a:normAutofit/>
+                    </a:bodyPr>
+                    <a:lstStyle/>
+                    <a:p>
+                      <a:pPr algn="ctr"/>
+                      <a:r>
+                        <a:rPr sz="1200" b="0">
+                          <a:solidFill>
+                            <a:srgbClr val="293A45"/>
+                          </a:solidFill>
+                          <a:latin typeface="Arial"/>
+                          <a:ea typeface="Arial"/>
+                          <a:cs typeface="Arial"/>
+                        </a:rPr>
+                        <a:t>I069</a:t>
+                      </a:r>
+                    </a:p>
+                  </a:txBody>
+                  <a:tcPr marL="91440" marR="91440" marT="45720" marB="45720" anchor="ctr">
+                    <a:lnR w="9525">
+                      <a:solidFill>
+                        <a:srgbClr val="D5DEE3"/>
+                      </a:solidFill>
+                      <a:prstDash val="solid"/>
+                    </a:lnR>
+                    <a:lnB w="9525">
+                      <a:solidFill>
+                        <a:srgbClr val="D5DEE3"/>
+                      </a:solidFill>
+                      <a:prstDash val="solid"/>
+                    </a:lnB>
+                    <a:solidFill>
+                      <a:srgbClr val="FFFFFF"/>
+                    </a:solidFill>
+                  </a:tcPr>
+                </a:tc>
+                <a:tc>
+                  <a:txBody>
+                    <a:bodyPr wrap="square" lIns="76200" tIns="47625" rIns="57150" bIns="47625">
+                      <a:normAutofit/>
+                    </a:bodyPr>
+                    <a:lstStyle/>
+                    <a:p>
+                      <a:pPr algn="ctr"/>
+                      <a:r>
+                        <a:rPr sz="1200" b="0">
+                          <a:solidFill>
+                            <a:srgbClr val="293A45"/>
+                          </a:solidFill>
+                          <a:latin typeface="Arial"/>
+                          <a:ea typeface="Arial"/>
+                          <a:cs typeface="Arial"/>
+                        </a:rPr>
+                        <a:t>Slides 8-12: Data, metrics and experiments</a:t>
+                      </a:r>
+                    </a:p>
+                  </a:txBody>
+                  <a:tcPr marL="91440" marR="91440" marT="45720" marB="45720" anchor="ctr">
+                    <a:lnR w="9525">
+                      <a:solidFill>
+                        <a:srgbClr val="D5DEE3"/>
+                      </a:solidFill>
+                      <a:prstDash val="solid"/>
+                    </a:lnR>
+                    <a:lnB w="9525">
+                      <a:solidFill>
+                        <a:srgbClr val="D5DEE3"/>
+                      </a:solidFill>
+                      <a:prstDash val="solid"/>
+                    </a:lnB>
+                    <a:solidFill>
+                      <a:srgbClr val="FFFFFF"/>
+                    </a:solidFill>
+                  </a:tcPr>
+                </a:tc>
+              </a:tr>
+              <a:tr h="419100">
+                <a:tc>
+                  <a:txBody>
+                    <a:bodyPr wrap="square" lIns="76200" tIns="47625" rIns="57150" bIns="47625">
+                      <a:normAutofit/>
+                    </a:bodyPr>
+                    <a:lstStyle/>
+                    <a:p>
+                      <a:pPr algn="l"/>
+                      <a:r>
+                        <a:rPr sz="1200" b="1">
+                          <a:solidFill>
+                            <a:srgbClr val="293A45"/>
+                          </a:solidFill>
+                          <a:latin typeface="Arial"/>
+                          <a:ea typeface="Arial"/>
+                          <a:cs typeface="Arial"/>
+                        </a:rPr>
+                        <a:t>Shawn Mendes</a:t>
+                      </a:r>
+                    </a:p>
+                  </a:txBody>
+                  <a:tcPr marL="91440" marR="91440" marT="45720" marB="45720" anchor="ctr">
+                    <a:lnL w="9525">
+                      <a:solidFill>
+                        <a:srgbClr val="D5DEE3"/>
+                      </a:solidFill>
+                      <a:prstDash val="solid"/>
+                    </a:lnL>
+                    <a:lnR w="9525">
+                      <a:solidFill>
+                        <a:srgbClr val="D5DEE3"/>
+                      </a:solidFill>
+                      <a:prstDash val="solid"/>
+                    </a:lnR>
+                    <a:lnB w="9525">
+                      <a:solidFill>
+                        <a:srgbClr val="D5DEE3"/>
+                      </a:solidFill>
+                      <a:prstDash val="solid"/>
+                    </a:lnB>
+                    <a:solidFill>
+                      <a:srgbClr val="F3F6F7"/>
+                    </a:solidFill>
+                  </a:tcPr>
+                </a:tc>
+                <a:tc>
+                  <a:txBody>
+                    <a:bodyPr wrap="square" lIns="76200" tIns="47625" rIns="57150" bIns="47625">
+                      <a:normAutofit/>
+                    </a:bodyPr>
+                    <a:lstStyle/>
+                    <a:p>
+                      <a:pPr algn="ctr"/>
+                      <a:r>
+                        <a:rPr sz="1200" b="0">
+                          <a:solidFill>
+                            <a:srgbClr val="293A45"/>
+                          </a:solidFill>
+                          <a:latin typeface="Arial"/>
+                          <a:ea typeface="Arial"/>
+                          <a:cs typeface="Arial"/>
+                        </a:rPr>
+                        <a:t>I077</a:t>
+                      </a:r>
+                    </a:p>
+                  </a:txBody>
+                  <a:tcPr marL="91440" marR="91440" marT="45720" marB="45720" anchor="ctr">
+                    <a:lnR w="9525">
+                      <a:solidFill>
+                        <a:srgbClr val="D5DEE3"/>
+                      </a:solidFill>
+                      <a:prstDash val="solid"/>
+                    </a:lnR>
+                    <a:lnB w="9525">
+                      <a:solidFill>
+                        <a:srgbClr val="D5DEE3"/>
+                      </a:solidFill>
+                      <a:prstDash val="solid"/>
+                    </a:lnB>
+                    <a:solidFill>
+                      <a:srgbClr val="F3F6F7"/>
+                    </a:solidFill>
+                  </a:tcPr>
+                </a:tc>
+                <a:tc>
+                  <a:txBody>
+                    <a:bodyPr wrap="square" lIns="76200" tIns="47625" rIns="57150" bIns="47625">
+                      <a:normAutofit/>
+                    </a:bodyPr>
+                    <a:lstStyle/>
+                    <a:p>
+                      <a:pPr algn="ctr"/>
+                      <a:r>
+                        <a:rPr sz="1200" b="0">
+                          <a:solidFill>
+                            <a:srgbClr val="293A45"/>
+                          </a:solidFill>
+                          <a:latin typeface="Arial"/>
+                          <a:ea typeface="Arial"/>
+                          <a:cs typeface="Arial"/>
+                        </a:rPr>
+                        <a:t>Slides 13-16: Analysis and conclusions</a:t>
                       </a:r>
                     </a:p>
                   </a:txBody>
@@ -15785,7 +16035,7 @@
           <p:cNvPr id="5" name="section-heading">
             <a:extLst xmlns:a="http://schemas.openxmlformats.org/drawingml/2006/main">
               <a:ext uri="{FF2B5EF4-FFF2-40B4-BE49-F238E27FC236}">
-                <a16:creationId xmlns:a16="http://schemas.microsoft.com/office/drawing/2014/main" id="{C8E0CDC4-308F-49A9-9DB4-A74B73B935A1}"/>
+                <a16:creationId xmlns:a16="http://schemas.microsoft.com/office/drawing/2014/main" id="{4985D101-E4BA-4EEA-809D-F9B339986A7C}"/>
               </a:ext>
             </a:extLst>
           </p:cNvPr>
@@ -15944,7 +16194,7 @@
           <p:cNvPr id="6" name="viva-prompts">
             <a:extLst xmlns:a="http://schemas.openxmlformats.org/drawingml/2006/main">
               <a:ext uri="{FF2B5EF4-FFF2-40B4-BE49-F238E27FC236}">
-                <a16:creationId xmlns:a16="http://schemas.microsoft.com/office/drawing/2014/main" id="{311B147A-242C-4036-AED7-BCCEF2596E35}"/>
+                <a16:creationId xmlns:a16="http://schemas.microsoft.com/office/drawing/2014/main" id="{7B5AD06E-E06B-4DFA-90A2-53F519CAB8D8}"/>
               </a:ext>
             </a:extLst>
           </p:cNvPr>
@@ -16159,7 +16409,7 @@
     </p:spTree>
     <p:extLst>
       <p:ext uri="{BB962C8B-B14F-4D97-AF65-F5344CB8AC3E}">
-        <p14:creationId xmlns:p14="http://schemas.microsoft.com/office/powerpoint/2010/main" val="1292589473"/>
+        <p14:creationId xmlns:p14="http://schemas.microsoft.com/office/powerpoint/2010/main" val="226470075"/>
       </p:ext>
     </p:extLst>
   </p:cSld>
@@ -16190,7 +16440,7 @@
           <p:cNvPr id="12" name="slide-title">
             <a:extLst xmlns:a="http://schemas.openxmlformats.org/drawingml/2006/main">
               <a:ext uri="{FF2B5EF4-FFF2-40B4-BE49-F238E27FC236}">
-                <a16:creationId xmlns:a16="http://schemas.microsoft.com/office/drawing/2014/main" id="{9B596ACE-4A15-4342-B5F1-AD29C366B512}"/>
+                <a16:creationId xmlns:a16="http://schemas.microsoft.com/office/drawing/2014/main" id="{4FF17049-92EF-4661-9246-B1061E5E6BA1}"/>
               </a:ext>
             </a:extLst>
           </p:cNvPr>
@@ -16349,7 +16599,7 @@
           <p:cNvPr id="2" name="divider">
             <a:extLst xmlns:a="http://schemas.openxmlformats.org/drawingml/2006/main">
               <a:ext uri="{FF2B5EF4-FFF2-40B4-BE49-F238E27FC236}">
-                <a16:creationId xmlns:a16="http://schemas.microsoft.com/office/drawing/2014/main" id="{F0D9D02E-0342-452B-B7DA-189AAE573BBD}"/>
+                <a16:creationId xmlns:a16="http://schemas.microsoft.com/office/drawing/2014/main" id="{E194057C-7C87-47CA-AB21-AC54AF9A9754}"/>
               </a:ext>
             </a:extLst>
           </p:cNvPr>
@@ -16382,7 +16632,7 @@
           <p:cNvPr id="3" name="slide-subtitle">
             <a:extLst xmlns:a="http://schemas.openxmlformats.org/drawingml/2006/main">
               <a:ext uri="{FF2B5EF4-FFF2-40B4-BE49-F238E27FC236}">
-                <a16:creationId xmlns:a16="http://schemas.microsoft.com/office/drawing/2014/main" id="{4AB6A291-56ED-45C7-A6E9-871EE95788F3}"/>
+                <a16:creationId xmlns:a16="http://schemas.microsoft.com/office/drawing/2014/main" id="{F4AEB3B2-7D05-4A9E-A86F-83C0E7959E8C}"/>
               </a:ext>
             </a:extLst>
           </p:cNvPr>
@@ -16541,7 +16791,7 @@
           <p:cNvPr id="4" name="divider">
             <a:extLst xmlns:a="http://schemas.openxmlformats.org/drawingml/2006/main">
               <a:ext uri="{FF2B5EF4-FFF2-40B4-BE49-F238E27FC236}">
-                <a16:creationId xmlns:a16="http://schemas.microsoft.com/office/drawing/2014/main" id="{95AC113A-68A0-4D70-8F06-CC931DE71BA5}"/>
+                <a16:creationId xmlns:a16="http://schemas.microsoft.com/office/drawing/2014/main" id="{A9DCD2B3-CA6C-4A8F-AAB4-B46B908EE164}"/>
               </a:ext>
             </a:extLst>
           </p:cNvPr>
@@ -16574,7 +16824,7 @@
           <p:cNvPr id="5" name="column-title">
             <a:extLst xmlns:a="http://schemas.openxmlformats.org/drawingml/2006/main">
               <a:ext uri="{FF2B5EF4-FFF2-40B4-BE49-F238E27FC236}">
-                <a16:creationId xmlns:a16="http://schemas.microsoft.com/office/drawing/2014/main" id="{0CC7E5F8-4DA2-4F13-B989-CD54BDF0EE82}"/>
+                <a16:creationId xmlns:a16="http://schemas.microsoft.com/office/drawing/2014/main" id="{1E85A555-71ED-4B30-B3B2-56449E73CADA}"/>
               </a:ext>
             </a:extLst>
           </p:cNvPr>
@@ -16733,7 +16983,7 @@
           <p:cNvPr id="6" name="column-copy">
             <a:extLst xmlns:a="http://schemas.openxmlformats.org/drawingml/2006/main">
               <a:ext uri="{FF2B5EF4-FFF2-40B4-BE49-F238E27FC236}">
-                <a16:creationId xmlns:a16="http://schemas.microsoft.com/office/drawing/2014/main" id="{6A7616BD-58EF-4587-8FDC-60AF450278A1}"/>
+                <a16:creationId xmlns:a16="http://schemas.microsoft.com/office/drawing/2014/main" id="{FEB86E8F-D088-4D86-90E8-959668CEEFC9}"/>
               </a:ext>
             </a:extLst>
           </p:cNvPr>
@@ -16896,7 +17146,7 @@
           <p:cNvPr id="7" name="divider">
             <a:extLst xmlns:a="http://schemas.openxmlformats.org/drawingml/2006/main">
               <a:ext uri="{FF2B5EF4-FFF2-40B4-BE49-F238E27FC236}">
-                <a16:creationId xmlns:a16="http://schemas.microsoft.com/office/drawing/2014/main" id="{8247E256-4CD8-4B85-AAB6-D1664D66AB58}"/>
+                <a16:creationId xmlns:a16="http://schemas.microsoft.com/office/drawing/2014/main" id="{F84EC8C0-41B4-43FC-B619-50E355F45118}"/>
               </a:ext>
             </a:extLst>
           </p:cNvPr>
@@ -16929,7 +17179,7 @@
           <p:cNvPr id="8" name="column-title">
             <a:extLst xmlns:a="http://schemas.openxmlformats.org/drawingml/2006/main">
               <a:ext uri="{FF2B5EF4-FFF2-40B4-BE49-F238E27FC236}">
-                <a16:creationId xmlns:a16="http://schemas.microsoft.com/office/drawing/2014/main" id="{A4C85BDB-7C9C-4249-95A5-F80094162D9C}"/>
+                <a16:creationId xmlns:a16="http://schemas.microsoft.com/office/drawing/2014/main" id="{F7ECDB3B-FF75-41FC-A8F6-2E82CA5DD61F}"/>
               </a:ext>
             </a:extLst>
           </p:cNvPr>
@@ -17088,7 +17338,7 @@
           <p:cNvPr id="9" name="column-copy">
             <a:extLst xmlns:a="http://schemas.openxmlformats.org/drawingml/2006/main">
               <a:ext uri="{FF2B5EF4-FFF2-40B4-BE49-F238E27FC236}">
-                <a16:creationId xmlns:a16="http://schemas.microsoft.com/office/drawing/2014/main" id="{D4F1E0CD-98E9-4613-8D70-E2D225C03994}"/>
+                <a16:creationId xmlns:a16="http://schemas.microsoft.com/office/drawing/2014/main" id="{9F1A3638-DC4E-49EC-9230-94DA12FEFE53}"/>
               </a:ext>
             </a:extLst>
           </p:cNvPr>
@@ -17251,7 +17501,7 @@
           <p:cNvPr id="10" name="divider">
             <a:extLst xmlns:a="http://schemas.openxmlformats.org/drawingml/2006/main">
               <a:ext uri="{FF2B5EF4-FFF2-40B4-BE49-F238E27FC236}">
-                <a16:creationId xmlns:a16="http://schemas.microsoft.com/office/drawing/2014/main" id="{C6527F05-B75D-4133-AE0B-2A8768BE7941}"/>
+                <a16:creationId xmlns:a16="http://schemas.microsoft.com/office/drawing/2014/main" id="{876B8115-33B2-48B3-ABED-DAE660A7B9C5}"/>
               </a:ext>
             </a:extLst>
           </p:cNvPr>
@@ -17284,7 +17534,7 @@
           <p:cNvPr id="11" name="scope-statement">
             <a:extLst xmlns:a="http://schemas.openxmlformats.org/drawingml/2006/main">
               <a:ext uri="{FF2B5EF4-FFF2-40B4-BE49-F238E27FC236}">
-                <a16:creationId xmlns:a16="http://schemas.microsoft.com/office/drawing/2014/main" id="{EA70E292-1787-44DF-AEF7-169A5CFCF003}"/>
+                <a16:creationId xmlns:a16="http://schemas.microsoft.com/office/drawing/2014/main" id="{A0BC33F6-C788-4981-B9A5-FCE21CE69797}"/>
               </a:ext>
             </a:extLst>
           </p:cNvPr>
@@ -17441,7 +17691,7 @@
     </p:spTree>
     <p:extLst>
       <p:ext uri="{BB962C8B-B14F-4D97-AF65-F5344CB8AC3E}">
-        <p14:creationId xmlns:p14="http://schemas.microsoft.com/office/powerpoint/2010/main" val="2058763728"/>
+        <p14:creationId xmlns:p14="http://schemas.microsoft.com/office/powerpoint/2010/main" val="376438318"/>
       </p:ext>
     </p:extLst>
   </p:cSld>
@@ -17472,7 +17722,7 @@
           <p:cNvPr id="12" name="slide-title">
             <a:extLst xmlns:a="http://schemas.openxmlformats.org/drawingml/2006/main">
               <a:ext uri="{FF2B5EF4-FFF2-40B4-BE49-F238E27FC236}">
-                <a16:creationId xmlns:a16="http://schemas.microsoft.com/office/drawing/2014/main" id="{CA5286AC-1C71-4917-B2CB-0BDD7FBC169B}"/>
+                <a16:creationId xmlns:a16="http://schemas.microsoft.com/office/drawing/2014/main" id="{548F6263-A3F6-4B37-8DD0-FC6AD10CF425}"/>
               </a:ext>
             </a:extLst>
           </p:cNvPr>
@@ -17631,7 +17881,7 @@
           <p:cNvPr id="2" name="divider">
             <a:extLst xmlns:a="http://schemas.openxmlformats.org/drawingml/2006/main">
               <a:ext uri="{FF2B5EF4-FFF2-40B4-BE49-F238E27FC236}">
-                <a16:creationId xmlns:a16="http://schemas.microsoft.com/office/drawing/2014/main" id="{CE198D57-3DF1-4146-A590-45E0D574A1A2}"/>
+                <a16:creationId xmlns:a16="http://schemas.microsoft.com/office/drawing/2014/main" id="{8268A60C-64B8-48A2-BEF8-5CCFAAF03F5E}"/>
               </a:ext>
             </a:extLst>
           </p:cNvPr>
@@ -17664,7 +17914,7 @@
           <p:cNvPr id="3" name="slide-subtitle">
             <a:extLst xmlns:a="http://schemas.openxmlformats.org/drawingml/2006/main">
               <a:ext uri="{FF2B5EF4-FFF2-40B4-BE49-F238E27FC236}">
-                <a16:creationId xmlns:a16="http://schemas.microsoft.com/office/drawing/2014/main" id="{4B2E9359-53D5-47F4-BC15-589E2214680D}"/>
+                <a16:creationId xmlns:a16="http://schemas.microsoft.com/office/drawing/2014/main" id="{DF39930B-F55A-4876-946D-075534F0B2A6}"/>
               </a:ext>
             </a:extLst>
           </p:cNvPr>
@@ -17823,7 +18073,7 @@
           <p:cNvPr id="4" name="divider">
             <a:extLst xmlns:a="http://schemas.openxmlformats.org/drawingml/2006/main">
               <a:ext uri="{FF2B5EF4-FFF2-40B4-BE49-F238E27FC236}">
-                <a16:creationId xmlns:a16="http://schemas.microsoft.com/office/drawing/2014/main" id="{2AA12A5D-4F01-4EC7-AA1B-DD8A6FAB6561}"/>
+                <a16:creationId xmlns:a16="http://schemas.microsoft.com/office/drawing/2014/main" id="{9F56B688-DE35-4D76-A7F6-E2D827417539}"/>
               </a:ext>
             </a:extLst>
           </p:cNvPr>
@@ -17856,7 +18106,7 @@
           <p:cNvPr id="5" name="column-title">
             <a:extLst xmlns:a="http://schemas.openxmlformats.org/drawingml/2006/main">
               <a:ext uri="{FF2B5EF4-FFF2-40B4-BE49-F238E27FC236}">
-                <a16:creationId xmlns:a16="http://schemas.microsoft.com/office/drawing/2014/main" id="{0E8A9804-BCEA-4E04-B733-9882FA11F04C}"/>
+                <a16:creationId xmlns:a16="http://schemas.microsoft.com/office/drawing/2014/main" id="{171CB8EA-16FC-4971-B3AD-94FB30D0291A}"/>
               </a:ext>
             </a:extLst>
           </p:cNvPr>
@@ -18015,7 +18265,7 @@
           <p:cNvPr id="6" name="column-copy">
             <a:extLst xmlns:a="http://schemas.openxmlformats.org/drawingml/2006/main">
               <a:ext uri="{FF2B5EF4-FFF2-40B4-BE49-F238E27FC236}">
-                <a16:creationId xmlns:a16="http://schemas.microsoft.com/office/drawing/2014/main" id="{9A7D03FC-4CD0-43F5-89C0-CD4BE5A8C84C}"/>
+                <a16:creationId xmlns:a16="http://schemas.microsoft.com/office/drawing/2014/main" id="{3658FA63-07E3-4475-9B50-B098B7186209}"/>
               </a:ext>
             </a:extLst>
           </p:cNvPr>
@@ -18178,7 +18428,7 @@
           <p:cNvPr id="7" name="divider">
             <a:extLst xmlns:a="http://schemas.openxmlformats.org/drawingml/2006/main">
               <a:ext uri="{FF2B5EF4-FFF2-40B4-BE49-F238E27FC236}">
-                <a16:creationId xmlns:a16="http://schemas.microsoft.com/office/drawing/2014/main" id="{225BD678-622C-4F99-AB69-F80F215F75E0}"/>
+                <a16:creationId xmlns:a16="http://schemas.microsoft.com/office/drawing/2014/main" id="{89BEC6D3-B3D6-4588-8EAA-3E114DF5D8C4}"/>
               </a:ext>
             </a:extLst>
           </p:cNvPr>
@@ -18211,7 +18461,7 @@
           <p:cNvPr id="8" name="column-title">
             <a:extLst xmlns:a="http://schemas.openxmlformats.org/drawingml/2006/main">
               <a:ext uri="{FF2B5EF4-FFF2-40B4-BE49-F238E27FC236}">
-                <a16:creationId xmlns:a16="http://schemas.microsoft.com/office/drawing/2014/main" id="{158C1FBD-73A1-415C-B0A0-E45DE81A20AD}"/>
+                <a16:creationId xmlns:a16="http://schemas.microsoft.com/office/drawing/2014/main" id="{7A472F97-1197-442F-83A6-62B021247CD4}"/>
               </a:ext>
             </a:extLst>
           </p:cNvPr>
@@ -18370,7 +18620,7 @@
           <p:cNvPr id="9" name="column-copy">
             <a:extLst xmlns:a="http://schemas.openxmlformats.org/drawingml/2006/main">
               <a:ext uri="{FF2B5EF4-FFF2-40B4-BE49-F238E27FC236}">
-                <a16:creationId xmlns:a16="http://schemas.microsoft.com/office/drawing/2014/main" id="{56E6CFFC-FDD0-45DA-B35A-BB97E5BECB17}"/>
+                <a16:creationId xmlns:a16="http://schemas.microsoft.com/office/drawing/2014/main" id="{B7B8AB45-1975-4E67-AFA8-2B489FC2DFA0}"/>
               </a:ext>
             </a:extLst>
           </p:cNvPr>
@@ -18533,7 +18783,7 @@
           <p:cNvPr id="10" name="divider">
             <a:extLst xmlns:a="http://schemas.openxmlformats.org/drawingml/2006/main">
               <a:ext uri="{FF2B5EF4-FFF2-40B4-BE49-F238E27FC236}">
-                <a16:creationId xmlns:a16="http://schemas.microsoft.com/office/drawing/2014/main" id="{C3B83146-962B-44B7-8EA1-FE7246AD3A44}"/>
+                <a16:creationId xmlns:a16="http://schemas.microsoft.com/office/drawing/2014/main" id="{F0291844-3496-4074-BF24-FE1AC633C1AB}"/>
               </a:ext>
             </a:extLst>
           </p:cNvPr>
@@ -18566,7 +18816,7 @@
           <p:cNvPr id="11" name="project-contribution">
             <a:extLst xmlns:a="http://schemas.openxmlformats.org/drawingml/2006/main">
               <a:ext uri="{FF2B5EF4-FFF2-40B4-BE49-F238E27FC236}">
-                <a16:creationId xmlns:a16="http://schemas.microsoft.com/office/drawing/2014/main" id="{E108D22E-0A3D-41AE-9E92-40FAB80AC6D6}"/>
+                <a16:creationId xmlns:a16="http://schemas.microsoft.com/office/drawing/2014/main" id="{652118E0-E6C3-429B-9CE5-8BEE3EFB6C46}"/>
               </a:ext>
             </a:extLst>
           </p:cNvPr>
@@ -18723,7 +18973,7 @@
     </p:spTree>
     <p:extLst>
       <p:ext uri="{BB962C8B-B14F-4D97-AF65-F5344CB8AC3E}">
-        <p14:creationId xmlns:p14="http://schemas.microsoft.com/office/powerpoint/2010/main" val="1094766957"/>
+        <p14:creationId xmlns:p14="http://schemas.microsoft.com/office/powerpoint/2010/main" val="1473568851"/>
       </p:ext>
     </p:extLst>
   </p:cSld>
@@ -18754,7 +19004,7 @@
           <p:cNvPr id="14" name="">
             <a:extLst xmlns:a="http://schemas.openxmlformats.org/drawingml/2006/main">
               <a:ext uri="{FF2B5EF4-FFF2-40B4-BE49-F238E27FC236}">
-                <a16:creationId xmlns:a16="http://schemas.microsoft.com/office/drawing/2014/main" id="{95026573-FBCB-4E54-898D-FB47E8ADF3D1}"/>
+                <a16:creationId xmlns:a16="http://schemas.microsoft.com/office/drawing/2014/main" id="{71900BA6-3AE6-4691-9785-82077BF9F781}"/>
               </a:ext>
             </a:extLst>
           </p:cNvPr>
@@ -18787,7 +19037,7 @@
           <p:cNvPr id="13" name="">
             <a:extLst xmlns:a="http://schemas.openxmlformats.org/drawingml/2006/main">
               <a:ext uri="{FF2B5EF4-FFF2-40B4-BE49-F238E27FC236}">
-                <a16:creationId xmlns:a16="http://schemas.microsoft.com/office/drawing/2014/main" id="{B65EFFD0-1AD7-4ACC-8B70-401660EE350F}"/>
+                <a16:creationId xmlns:a16="http://schemas.microsoft.com/office/drawing/2014/main" id="{7AEEBC54-F531-4A94-A40F-2E12CB71B27B}"/>
               </a:ext>
             </a:extLst>
           </p:cNvPr>
@@ -18822,7 +19072,7 @@
           <p:cNvPr id="12" name="">
             <a:extLst xmlns:a="http://schemas.openxmlformats.org/drawingml/2006/main">
               <a:ext uri="{FF2B5EF4-FFF2-40B4-BE49-F238E27FC236}">
-                <a16:creationId xmlns:a16="http://schemas.microsoft.com/office/drawing/2014/main" id="{32ABEDB0-4521-497F-BD65-6C4D79F56880}"/>
+                <a16:creationId xmlns:a16="http://schemas.microsoft.com/office/drawing/2014/main" id="{9A62B0C0-346C-47D9-8BFB-8A4CDDACDC1A}"/>
               </a:ext>
             </a:extLst>
           </p:cNvPr>
@@ -18857,7 +19107,7 @@
           <p:cNvPr id="11" name="">
             <a:extLst xmlns:a="http://schemas.openxmlformats.org/drawingml/2006/main">
               <a:ext uri="{FF2B5EF4-FFF2-40B4-BE49-F238E27FC236}">
-                <a16:creationId xmlns:a16="http://schemas.microsoft.com/office/drawing/2014/main" id="{9CED2B6F-AFC0-4101-BC4B-974D1BA9417B}"/>
+                <a16:creationId xmlns:a16="http://schemas.microsoft.com/office/drawing/2014/main" id="{AC2AED9D-3B4B-41C2-9D5E-BFFB48F3F012}"/>
               </a:ext>
             </a:extLst>
           </p:cNvPr>
@@ -18892,7 +19142,7 @@
           <p:cNvPr id="10" name="">
             <a:extLst xmlns:a="http://schemas.openxmlformats.org/drawingml/2006/main">
               <a:ext uri="{FF2B5EF4-FFF2-40B4-BE49-F238E27FC236}">
-                <a16:creationId xmlns:a16="http://schemas.microsoft.com/office/drawing/2014/main" id="{7BEE87A6-8A47-4E83-92BB-40444D9B264D}"/>
+                <a16:creationId xmlns:a16="http://schemas.microsoft.com/office/drawing/2014/main" id="{C2EA06DB-A3E3-4A47-821F-CB337C7A3A10}"/>
               </a:ext>
             </a:extLst>
           </p:cNvPr>
@@ -18927,7 +19177,7 @@
           <p:cNvPr id="16" name="slide-title">
             <a:extLst xmlns:a="http://schemas.openxmlformats.org/drawingml/2006/main">
               <a:ext uri="{FF2B5EF4-FFF2-40B4-BE49-F238E27FC236}">
-                <a16:creationId xmlns:a16="http://schemas.microsoft.com/office/drawing/2014/main" id="{7683E3D6-855E-49AD-A306-954597C64EBF}"/>
+                <a16:creationId xmlns:a16="http://schemas.microsoft.com/office/drawing/2014/main" id="{F908E1A2-A833-4356-B1CC-C2860ACE9225}"/>
               </a:ext>
             </a:extLst>
           </p:cNvPr>
@@ -19086,7 +19336,7 @@
           <p:cNvPr id="2" name="divider">
             <a:extLst xmlns:a="http://schemas.openxmlformats.org/drawingml/2006/main">
               <a:ext uri="{FF2B5EF4-FFF2-40B4-BE49-F238E27FC236}">
-                <a16:creationId xmlns:a16="http://schemas.microsoft.com/office/drawing/2014/main" id="{C6275183-3D8E-4FA0-B5BA-84763718CECF}"/>
+                <a16:creationId xmlns:a16="http://schemas.microsoft.com/office/drawing/2014/main" id="{1F0BDD0A-C29E-4804-8649-715DCB3EFA10}"/>
               </a:ext>
             </a:extLst>
           </p:cNvPr>
@@ -19119,7 +19369,7 @@
           <p:cNvPr id="3" name="slide-subtitle">
             <a:extLst xmlns:a="http://schemas.openxmlformats.org/drawingml/2006/main">
               <a:ext uri="{FF2B5EF4-FFF2-40B4-BE49-F238E27FC236}">
-                <a16:creationId xmlns:a16="http://schemas.microsoft.com/office/drawing/2014/main" id="{91823D97-EC14-45A0-A33B-E8CA7FE4FD06}"/>
+                <a16:creationId xmlns:a16="http://schemas.microsoft.com/office/drawing/2014/main" id="{AF0D8F0A-EBB1-490A-8DCC-30517B53EE70}"/>
               </a:ext>
             </a:extLst>
           </p:cNvPr>
@@ -19278,7 +19528,7 @@
           <p:cNvPr id="4" name="paper-explicit-inputs">
             <a:extLst xmlns:a="http://schemas.openxmlformats.org/drawingml/2006/main">
               <a:ext uri="{FF2B5EF4-FFF2-40B4-BE49-F238E27FC236}">
-                <a16:creationId xmlns:a16="http://schemas.microsoft.com/office/drawing/2014/main" id="{0530315B-6D48-4DF5-B1A0-1F691E063D0A}"/>
+                <a16:creationId xmlns:a16="http://schemas.microsoft.com/office/drawing/2014/main" id="{F901B263-CA53-4492-941D-1ECA8887B26A}"/>
               </a:ext>
             </a:extLst>
           </p:cNvPr>
@@ -19487,7 +19737,7 @@
           <p:cNvPr id="5" name="paper-implicit-inputs">
             <a:extLst xmlns:a="http://schemas.openxmlformats.org/drawingml/2006/main">
               <a:ext uri="{FF2B5EF4-FFF2-40B4-BE49-F238E27FC236}">
-                <a16:creationId xmlns:a16="http://schemas.microsoft.com/office/drawing/2014/main" id="{E64E50B2-7B95-4E30-85F8-ED290F52ECBB}"/>
+                <a16:creationId xmlns:a16="http://schemas.microsoft.com/office/drawing/2014/main" id="{D910B377-5437-4632-BA36-850CBE98CB9D}"/>
               </a:ext>
             </a:extLst>
           </p:cNvPr>
@@ -19673,7 +19923,7 @@
           <p:cNvPr id="6" name="paper-explicit-path">
             <a:extLst xmlns:a="http://schemas.openxmlformats.org/drawingml/2006/main">
               <a:ext uri="{FF2B5EF4-FFF2-40B4-BE49-F238E27FC236}">
-                <a16:creationId xmlns:a16="http://schemas.microsoft.com/office/drawing/2014/main" id="{7DCFD912-6592-4D74-A4F7-FA318DC65234}"/>
+                <a16:creationId xmlns:a16="http://schemas.microsoft.com/office/drawing/2014/main" id="{7DE3698A-DC4D-4816-8DB9-961BF840DDE6}"/>
               </a:ext>
             </a:extLst>
           </p:cNvPr>
@@ -19882,7 +20132,7 @@
           <p:cNvPr id="7" name="paper-implicit-path">
             <a:extLst xmlns:a="http://schemas.openxmlformats.org/drawingml/2006/main">
               <a:ext uri="{FF2B5EF4-FFF2-40B4-BE49-F238E27FC236}">
-                <a16:creationId xmlns:a16="http://schemas.microsoft.com/office/drawing/2014/main" id="{9DF4FC9F-8D9B-4EC5-B926-36786D27A2DA}"/>
+                <a16:creationId xmlns:a16="http://schemas.microsoft.com/office/drawing/2014/main" id="{451D87A2-F0BF-4130-98DD-FF7684938A56}"/>
               </a:ext>
             </a:extLst>
           </p:cNvPr>
@@ -20091,7 +20341,7 @@
           <p:cNvPr id="8" name="paper-fusion">
             <a:extLst xmlns:a="http://schemas.openxmlformats.org/drawingml/2006/main">
               <a:ext uri="{FF2B5EF4-FFF2-40B4-BE49-F238E27FC236}">
-                <a16:creationId xmlns:a16="http://schemas.microsoft.com/office/drawing/2014/main" id="{77592DB1-E225-4D7A-A840-3B3E3D4E4D4E}"/>
+                <a16:creationId xmlns:a16="http://schemas.microsoft.com/office/drawing/2014/main" id="{B53BB677-B05B-44DB-9194-A7A937692337}"/>
               </a:ext>
             </a:extLst>
           </p:cNvPr>
@@ -20300,7 +20550,7 @@
           <p:cNvPr id="9" name="paper-output">
             <a:extLst xmlns:a="http://schemas.openxmlformats.org/drawingml/2006/main">
               <a:ext uri="{FF2B5EF4-FFF2-40B4-BE49-F238E27FC236}">
-                <a16:creationId xmlns:a16="http://schemas.microsoft.com/office/drawing/2014/main" id="{5EF9507D-8123-40C7-87F2-8548603F0ACB}"/>
+                <a16:creationId xmlns:a16="http://schemas.microsoft.com/office/drawing/2014/main" id="{62DD0D51-9BA5-44C5-944C-0074702CCF83}"/>
               </a:ext>
             </a:extLst>
           </p:cNvPr>
@@ -20509,7 +20759,7 @@
           <p:cNvPr id="15" name="diagram-label">
             <a:extLst xmlns:a="http://schemas.openxmlformats.org/drawingml/2006/main">
               <a:ext uri="{FF2B5EF4-FFF2-40B4-BE49-F238E27FC236}">
-                <a16:creationId xmlns:a16="http://schemas.microsoft.com/office/drawing/2014/main" id="{A2B00577-02B5-4BCE-BF3E-BD7AF44CE06D}"/>
+                <a16:creationId xmlns:a16="http://schemas.microsoft.com/office/drawing/2014/main" id="{5EFD6424-21AD-468D-BBAD-D6DC59415B6B}"/>
               </a:ext>
             </a:extLst>
           </p:cNvPr>
@@ -20666,7 +20916,7 @@
     </p:spTree>
     <p:extLst>
       <p:ext uri="{BB962C8B-B14F-4D97-AF65-F5344CB8AC3E}">
-        <p14:creationId xmlns:p14="http://schemas.microsoft.com/office/powerpoint/2010/main" val="757536813"/>
+        <p14:creationId xmlns:p14="http://schemas.microsoft.com/office/powerpoint/2010/main" val="1619575873"/>
       </p:ext>
     </p:extLst>
   </p:cSld>
@@ -20697,7 +20947,7 @@
           <p:cNvPr id="14" name="">
             <a:extLst xmlns:a="http://schemas.openxmlformats.org/drawingml/2006/main">
               <a:ext uri="{FF2B5EF4-FFF2-40B4-BE49-F238E27FC236}">
-                <a16:creationId xmlns:a16="http://schemas.microsoft.com/office/drawing/2014/main" id="{1FF6E7A6-DFA8-4620-929B-0DC8F3B1F887}"/>
+                <a16:creationId xmlns:a16="http://schemas.microsoft.com/office/drawing/2014/main" id="{8149C890-91DF-4353-A763-DEC7B5F8DF7C}"/>
               </a:ext>
             </a:extLst>
           </p:cNvPr>
@@ -20730,7 +20980,7 @@
           <p:cNvPr id="13" name="">
             <a:extLst xmlns:a="http://schemas.openxmlformats.org/drawingml/2006/main">
               <a:ext uri="{FF2B5EF4-FFF2-40B4-BE49-F238E27FC236}">
-                <a16:creationId xmlns:a16="http://schemas.microsoft.com/office/drawing/2014/main" id="{6A451CD9-300E-4DFB-B10A-4ABAF8BD2AB9}"/>
+                <a16:creationId xmlns:a16="http://schemas.microsoft.com/office/drawing/2014/main" id="{E1A98124-D7D5-4472-8897-F45BF325F72F}"/>
               </a:ext>
             </a:extLst>
           </p:cNvPr>
@@ -20765,7 +21015,7 @@
           <p:cNvPr id="12" name="">
             <a:extLst xmlns:a="http://schemas.openxmlformats.org/drawingml/2006/main">
               <a:ext uri="{FF2B5EF4-FFF2-40B4-BE49-F238E27FC236}">
-                <a16:creationId xmlns:a16="http://schemas.microsoft.com/office/drawing/2014/main" id="{2B6046FC-168A-41FC-8335-44795E3422C1}"/>
+                <a16:creationId xmlns:a16="http://schemas.microsoft.com/office/drawing/2014/main" id="{6C20189A-D497-47FD-8B9A-012A65D1993D}"/>
               </a:ext>
             </a:extLst>
           </p:cNvPr>
@@ -20800,7 +21050,7 @@
           <p:cNvPr id="11" name="">
             <a:extLst xmlns:a="http://schemas.openxmlformats.org/drawingml/2006/main">
               <a:ext uri="{FF2B5EF4-FFF2-40B4-BE49-F238E27FC236}">
-                <a16:creationId xmlns:a16="http://schemas.microsoft.com/office/drawing/2014/main" id="{B24ED923-0D58-4D5E-9555-F80C3B27AEFA}"/>
+                <a16:creationId xmlns:a16="http://schemas.microsoft.com/office/drawing/2014/main" id="{4187B938-AFE1-48C6-A239-C96711DCC6AF}"/>
               </a:ext>
             </a:extLst>
           </p:cNvPr>
@@ -20833,7 +21083,7 @@
           <p:cNvPr id="10" name="">
             <a:extLst xmlns:a="http://schemas.openxmlformats.org/drawingml/2006/main">
               <a:ext uri="{FF2B5EF4-FFF2-40B4-BE49-F238E27FC236}">
-                <a16:creationId xmlns:a16="http://schemas.microsoft.com/office/drawing/2014/main" id="{1583F638-B925-4882-BF58-3127F4CBF332}"/>
+                <a16:creationId xmlns:a16="http://schemas.microsoft.com/office/drawing/2014/main" id="{9D9BA811-07C1-433A-9D54-AC6F6A18E6B9}"/>
               </a:ext>
             </a:extLst>
           </p:cNvPr>
@@ -20868,7 +21118,7 @@
           <p:cNvPr id="16" name="slide-title">
             <a:extLst xmlns:a="http://schemas.openxmlformats.org/drawingml/2006/main">
               <a:ext uri="{FF2B5EF4-FFF2-40B4-BE49-F238E27FC236}">
-                <a16:creationId xmlns:a16="http://schemas.microsoft.com/office/drawing/2014/main" id="{1036A927-78E3-4470-9791-C40897E296E4}"/>
+                <a16:creationId xmlns:a16="http://schemas.microsoft.com/office/drawing/2014/main" id="{AEF073BC-3953-455C-900C-0E31901A77DF}"/>
               </a:ext>
             </a:extLst>
           </p:cNvPr>
@@ -21027,7 +21277,7 @@
           <p:cNvPr id="2" name="divider">
             <a:extLst xmlns:a="http://schemas.openxmlformats.org/drawingml/2006/main">
               <a:ext uri="{FF2B5EF4-FFF2-40B4-BE49-F238E27FC236}">
-                <a16:creationId xmlns:a16="http://schemas.microsoft.com/office/drawing/2014/main" id="{A285D3A0-CDC9-4397-BAFF-000806E42332}"/>
+                <a16:creationId xmlns:a16="http://schemas.microsoft.com/office/drawing/2014/main" id="{480E80F8-05EE-43BB-A09B-9589E1CBCE55}"/>
               </a:ext>
             </a:extLst>
           </p:cNvPr>
@@ -21060,7 +21310,7 @@
           <p:cNvPr id="3" name="slide-subtitle">
             <a:extLst xmlns:a="http://schemas.openxmlformats.org/drawingml/2006/main">
               <a:ext uri="{FF2B5EF4-FFF2-40B4-BE49-F238E27FC236}">
-                <a16:creationId xmlns:a16="http://schemas.microsoft.com/office/drawing/2014/main" id="{78DE8042-31FF-4B56-AD75-5BEF449B2F8B}"/>
+                <a16:creationId xmlns:a16="http://schemas.microsoft.com/office/drawing/2014/main" id="{CB9144C0-C0B3-4C33-B03D-BFAC0271925F}"/>
               </a:ext>
             </a:extLst>
           </p:cNvPr>
@@ -21219,7 +21469,7 @@
           <p:cNvPr id="4" name="user-profile-fields">
             <a:extLst xmlns:a="http://schemas.openxmlformats.org/drawingml/2006/main">
               <a:ext uri="{FF2B5EF4-FFF2-40B4-BE49-F238E27FC236}">
-                <a16:creationId xmlns:a16="http://schemas.microsoft.com/office/drawing/2014/main" id="{D7D8D1B4-61C2-49D6-A5EB-9B48A279D59A}"/>
+                <a16:creationId xmlns:a16="http://schemas.microsoft.com/office/drawing/2014/main" id="{E3546BF1-AFCF-4A94-8D7A-3644E3202C54}"/>
               </a:ext>
             </a:extLst>
           </p:cNvPr>
@@ -21474,7 +21724,7 @@
           <p:cNvPr id="5" name="user-side-representation">
             <a:extLst xmlns:a="http://schemas.openxmlformats.org/drawingml/2006/main">
               <a:ext uri="{FF2B5EF4-FFF2-40B4-BE49-F238E27FC236}">
-                <a16:creationId xmlns:a16="http://schemas.microsoft.com/office/drawing/2014/main" id="{7CA91B7E-D8A4-4EC1-9242-20619E79571A}"/>
+                <a16:creationId xmlns:a16="http://schemas.microsoft.com/office/drawing/2014/main" id="{9956E565-EAB7-4A70-BC1A-592EEE10EC96}"/>
               </a:ext>
             </a:extLst>
           </p:cNvPr>
@@ -21729,7 +21979,7 @@
           <p:cNvPr id="6" name="item-genre-fields">
             <a:extLst xmlns:a="http://schemas.openxmlformats.org/drawingml/2006/main">
               <a:ext uri="{FF2B5EF4-FFF2-40B4-BE49-F238E27FC236}">
-                <a16:creationId xmlns:a16="http://schemas.microsoft.com/office/drawing/2014/main" id="{7FB9A8F2-4C09-456A-A581-FC434808E0A9}"/>
+                <a16:creationId xmlns:a16="http://schemas.microsoft.com/office/drawing/2014/main" id="{5D697218-330A-447D-BF34-AE4041975A55}"/>
               </a:ext>
             </a:extLst>
           </p:cNvPr>
@@ -21915,7 +22165,7 @@
           <p:cNvPr id="7" name="item-side-representation">
             <a:extLst xmlns:a="http://schemas.openxmlformats.org/drawingml/2006/main">
               <a:ext uri="{FF2B5EF4-FFF2-40B4-BE49-F238E27FC236}">
-                <a16:creationId xmlns:a16="http://schemas.microsoft.com/office/drawing/2014/main" id="{9C2EDAF6-017D-4FF7-B453-6448E598B769}"/>
+                <a16:creationId xmlns:a16="http://schemas.microsoft.com/office/drawing/2014/main" id="{E3F3ED43-A483-409F-8129-2B703DF26740}"/>
               </a:ext>
             </a:extLst>
           </p:cNvPr>
@@ -22124,7 +22374,7 @@
           <p:cNvPr id="8" name="side-vector-pair">
             <a:extLst xmlns:a="http://schemas.openxmlformats.org/drawingml/2006/main">
               <a:ext uri="{FF2B5EF4-FFF2-40B4-BE49-F238E27FC236}">
-                <a16:creationId xmlns:a16="http://schemas.microsoft.com/office/drawing/2014/main" id="{A1EA5DD0-8F06-4856-84F9-08DF954E4CB4}"/>
+                <a16:creationId xmlns:a16="http://schemas.microsoft.com/office/drawing/2014/main" id="{6F87E5A6-F61E-4FF9-936B-A0764471C88E}"/>
               </a:ext>
             </a:extLst>
           </p:cNvPr>
@@ -22361,7 +22611,7 @@
           <p:cNvPr id="9" name="outer-product-result">
             <a:extLst xmlns:a="http://schemas.openxmlformats.org/drawingml/2006/main">
               <a:ext uri="{FF2B5EF4-FFF2-40B4-BE49-F238E27FC236}">
-                <a16:creationId xmlns:a16="http://schemas.microsoft.com/office/drawing/2014/main" id="{EAC5D7EE-E280-4DA8-8E14-47C847309CD2}"/>
+                <a16:creationId xmlns:a16="http://schemas.microsoft.com/office/drawing/2014/main" id="{2CDEFB6A-66E0-41D6-A874-2C4990EA3811}"/>
               </a:ext>
             </a:extLst>
           </p:cNvPr>
@@ -22570,7 +22820,7 @@
           <p:cNvPr id="15" name="feature-note">
             <a:extLst xmlns:a="http://schemas.openxmlformats.org/drawingml/2006/main">
               <a:ext uri="{FF2B5EF4-FFF2-40B4-BE49-F238E27FC236}">
-                <a16:creationId xmlns:a16="http://schemas.microsoft.com/office/drawing/2014/main" id="{9CAECC9F-217C-452C-A657-F0D0A2E1C755}"/>
+                <a16:creationId xmlns:a16="http://schemas.microsoft.com/office/drawing/2014/main" id="{A263F8E0-83E4-4A86-B4A3-8426B7B6C7F8}"/>
               </a:ext>
             </a:extLst>
           </p:cNvPr>
@@ -22727,7 +22977,7 @@
     </p:spTree>
     <p:extLst>
       <p:ext uri="{BB962C8B-B14F-4D97-AF65-F5344CB8AC3E}">
-        <p14:creationId xmlns:p14="http://schemas.microsoft.com/office/powerpoint/2010/main" val="1007820960"/>
+        <p14:creationId xmlns:p14="http://schemas.microsoft.com/office/powerpoint/2010/main" val="1154256102"/>
       </p:ext>
     </p:extLst>
   </p:cSld>
@@ -22758,7 +23008,7 @@
           <p:cNvPr id="17" name="">
             <a:extLst xmlns:a="http://schemas.openxmlformats.org/drawingml/2006/main">
               <a:ext uri="{FF2B5EF4-FFF2-40B4-BE49-F238E27FC236}">
-                <a16:creationId xmlns:a16="http://schemas.microsoft.com/office/drawing/2014/main" id="{7D89151D-347A-4AD0-89DB-0EA0DBE5820E}"/>
+                <a16:creationId xmlns:a16="http://schemas.microsoft.com/office/drawing/2014/main" id="{CDA06184-8E03-40B8-A375-6B21BBF8A5CA}"/>
               </a:ext>
             </a:extLst>
           </p:cNvPr>
@@ -22793,7 +23043,7 @@
           <p:cNvPr id="16" name="">
             <a:extLst xmlns:a="http://schemas.openxmlformats.org/drawingml/2006/main">
               <a:ext uri="{FF2B5EF4-FFF2-40B4-BE49-F238E27FC236}">
-                <a16:creationId xmlns:a16="http://schemas.microsoft.com/office/drawing/2014/main" id="{A7285FBA-A46D-4B7C-8EEC-C4790E579B9A}"/>
+                <a16:creationId xmlns:a16="http://schemas.microsoft.com/office/drawing/2014/main" id="{0FA55ABC-6984-4D72-B0E4-886F8E11CAF8}"/>
               </a:ext>
             </a:extLst>
           </p:cNvPr>
@@ -22828,7 +23078,7 @@
           <p:cNvPr id="15" name="">
             <a:extLst xmlns:a="http://schemas.openxmlformats.org/drawingml/2006/main">
               <a:ext uri="{FF2B5EF4-FFF2-40B4-BE49-F238E27FC236}">
-                <a16:creationId xmlns:a16="http://schemas.microsoft.com/office/drawing/2014/main" id="{8EC30ECC-E6BB-4B68-9B7E-CC00A57A37F7}"/>
+                <a16:creationId xmlns:a16="http://schemas.microsoft.com/office/drawing/2014/main" id="{94855E99-EC55-4BB9-BF75-940CEBE4F5F3}"/>
               </a:ext>
             </a:extLst>
           </p:cNvPr>
@@ -22865,7 +23115,7 @@
           <p:cNvPr id="14" name="">
             <a:extLst xmlns:a="http://schemas.openxmlformats.org/drawingml/2006/main">
               <a:ext uri="{FF2B5EF4-FFF2-40B4-BE49-F238E27FC236}">
-                <a16:creationId xmlns:a16="http://schemas.microsoft.com/office/drawing/2014/main" id="{95F94F88-53AD-4CE3-A76C-FCD4E623D305}"/>
+                <a16:creationId xmlns:a16="http://schemas.microsoft.com/office/drawing/2014/main" id="{36E57442-A891-4DC6-9DD3-8EC61A7070B4}"/>
               </a:ext>
             </a:extLst>
           </p:cNvPr>
@@ -22898,7 +23148,7 @@
           <p:cNvPr id="13" name="">
             <a:extLst xmlns:a="http://schemas.openxmlformats.org/drawingml/2006/main">
               <a:ext uri="{FF2B5EF4-FFF2-40B4-BE49-F238E27FC236}">
-                <a16:creationId xmlns:a16="http://schemas.microsoft.com/office/drawing/2014/main" id="{6AFCF85D-2F5F-4F10-85F1-E7E4B9A3D0B0}"/>
+                <a16:creationId xmlns:a16="http://schemas.microsoft.com/office/drawing/2014/main" id="{F027EA31-790A-48A7-B3E6-2325FCBFF62D}"/>
               </a:ext>
             </a:extLst>
           </p:cNvPr>
@@ -22933,7 +23183,7 @@
           <p:cNvPr id="12" name="">
             <a:extLst xmlns:a="http://schemas.openxmlformats.org/drawingml/2006/main">
               <a:ext uri="{FF2B5EF4-FFF2-40B4-BE49-F238E27FC236}">
-                <a16:creationId xmlns:a16="http://schemas.microsoft.com/office/drawing/2014/main" id="{089FD802-4E6F-43E7-89CA-71B52FD7A0B1}"/>
+                <a16:creationId xmlns:a16="http://schemas.microsoft.com/office/drawing/2014/main" id="{6665600B-E285-42BA-AE0F-7C0561813AEF}"/>
               </a:ext>
             </a:extLst>
           </p:cNvPr>
@@ -22968,7 +23218,7 @@
           <p:cNvPr id="11" name="">
             <a:extLst xmlns:a="http://schemas.openxmlformats.org/drawingml/2006/main">
               <a:ext uri="{FF2B5EF4-FFF2-40B4-BE49-F238E27FC236}">
-                <a16:creationId xmlns:a16="http://schemas.microsoft.com/office/drawing/2014/main" id="{2944AE24-2AA2-4926-992E-6B215DE26C21}"/>
+                <a16:creationId xmlns:a16="http://schemas.microsoft.com/office/drawing/2014/main" id="{1A9403FE-1BB5-48CA-B8A4-2EC6EBFF3938}"/>
               </a:ext>
             </a:extLst>
           </p:cNvPr>
@@ -23003,7 +23253,7 @@
           <p:cNvPr id="19" name="slide-title">
             <a:extLst xmlns:a="http://schemas.openxmlformats.org/drawingml/2006/main">
               <a:ext uri="{FF2B5EF4-FFF2-40B4-BE49-F238E27FC236}">
-                <a16:creationId xmlns:a16="http://schemas.microsoft.com/office/drawing/2014/main" id="{2BD6DBE3-90DE-4783-B342-09571C3D7888}"/>
+                <a16:creationId xmlns:a16="http://schemas.microsoft.com/office/drawing/2014/main" id="{25980D72-1CCC-4669-BFA3-504FF9F4DD84}"/>
               </a:ext>
             </a:extLst>
           </p:cNvPr>
@@ -23162,7 +23412,7 @@
           <p:cNvPr id="2" name="divider">
             <a:extLst xmlns:a="http://schemas.openxmlformats.org/drawingml/2006/main">
               <a:ext uri="{FF2B5EF4-FFF2-40B4-BE49-F238E27FC236}">
-                <a16:creationId xmlns:a16="http://schemas.microsoft.com/office/drawing/2014/main" id="{2CA38795-49CC-4A6B-A548-98AFF685C81C}"/>
+                <a16:creationId xmlns:a16="http://schemas.microsoft.com/office/drawing/2014/main" id="{18A8BC33-2C96-4221-B87F-938FE9C9F8A8}"/>
               </a:ext>
             </a:extLst>
           </p:cNvPr>
@@ -23195,7 +23445,7 @@
           <p:cNvPr id="3" name="slide-subtitle">
             <a:extLst xmlns:a="http://schemas.openxmlformats.org/drawingml/2006/main">
               <a:ext uri="{FF2B5EF4-FFF2-40B4-BE49-F238E27FC236}">
-                <a16:creationId xmlns:a16="http://schemas.microsoft.com/office/drawing/2014/main" id="{BEBC8507-0E67-4A39-88C9-2DB793CE6E09}"/>
+                <a16:creationId xmlns:a16="http://schemas.microsoft.com/office/drawing/2014/main" id="{DB31E204-78E3-4BE2-B425-E8EC9F7DB713}"/>
               </a:ext>
             </a:extLst>
           </p:cNvPr>
@@ -23354,7 +23604,7 @@
           <p:cNvPr id="4" name="explicit-user-vector">
             <a:extLst xmlns:a="http://schemas.openxmlformats.org/drawingml/2006/main">
               <a:ext uri="{FF2B5EF4-FFF2-40B4-BE49-F238E27FC236}">
-                <a16:creationId xmlns:a16="http://schemas.microsoft.com/office/drawing/2014/main" id="{8179B8D0-8EFB-4803-B1D3-5BC355588B18}"/>
+                <a16:creationId xmlns:a16="http://schemas.microsoft.com/office/drawing/2014/main" id="{1E80F033-A78A-4BAD-94BA-C0EDBF15D08C}"/>
               </a:ext>
             </a:extLst>
           </p:cNvPr>
@@ -23540,7 +23790,7 @@
           <p:cNvPr id="5" name="explicit-item-vector">
             <a:extLst xmlns:a="http://schemas.openxmlformats.org/drawingml/2006/main">
               <a:ext uri="{FF2B5EF4-FFF2-40B4-BE49-F238E27FC236}">
-                <a16:creationId xmlns:a16="http://schemas.microsoft.com/office/drawing/2014/main" id="{98037330-A9A4-4AFE-9B63-AC83867B5FBD}"/>
+                <a16:creationId xmlns:a16="http://schemas.microsoft.com/office/drawing/2014/main" id="{BBA6E705-2EB7-4067-ACBA-2577BAF1E672}"/>
               </a:ext>
             </a:extLst>
           </p:cNvPr>
@@ -23726,7 +23976,7 @@
           <p:cNvPr id="6" name="explicit-outer-product">
             <a:extLst xmlns:a="http://schemas.openxmlformats.org/drawingml/2006/main">
               <a:ext uri="{FF2B5EF4-FFF2-40B4-BE49-F238E27FC236}">
-                <a16:creationId xmlns:a16="http://schemas.microsoft.com/office/drawing/2014/main" id="{EAD852B2-CFA1-4845-A187-981B3C7A862E}"/>
+                <a16:creationId xmlns:a16="http://schemas.microsoft.com/office/drawing/2014/main" id="{FB9C83DC-42E0-45B6-9CCD-63024413E067}"/>
               </a:ext>
             </a:extLst>
           </p:cNvPr>
@@ -23935,7 +24185,7 @@
           <p:cNvPr id="7" name="project-convolution">
             <a:extLst xmlns:a="http://schemas.openxmlformats.org/drawingml/2006/main">
               <a:ext uri="{FF2B5EF4-FFF2-40B4-BE49-F238E27FC236}">
-                <a16:creationId xmlns:a16="http://schemas.microsoft.com/office/drawing/2014/main" id="{793AE00F-0C66-43A7-896E-C2FD2A1EC127}"/>
+                <a16:creationId xmlns:a16="http://schemas.microsoft.com/office/drawing/2014/main" id="{1183BF11-CE60-4716-94EE-1D5F7C48D44D}"/>
               </a:ext>
             </a:extLst>
           </p:cNvPr>
@@ -24167,7 +24417,7 @@
           <p:cNvPr id="8" name="project-pooling">
             <a:extLst xmlns:a="http://schemas.openxmlformats.org/drawingml/2006/main">
               <a:ext uri="{FF2B5EF4-FFF2-40B4-BE49-F238E27FC236}">
-                <a16:creationId xmlns:a16="http://schemas.microsoft.com/office/drawing/2014/main" id="{07EA7B55-4AC7-48BC-AFC7-B8084FF09855}"/>
+                <a16:creationId xmlns:a16="http://schemas.microsoft.com/office/drawing/2014/main" id="{A51A525E-1D61-4C32-B46D-453A03ED9C72}"/>
               </a:ext>
             </a:extLst>
           </p:cNvPr>
@@ -24376,7 +24626,7 @@
           <p:cNvPr id="9" name="project-global">
             <a:extLst xmlns:a="http://schemas.openxmlformats.org/drawingml/2006/main">
               <a:ext uri="{FF2B5EF4-FFF2-40B4-BE49-F238E27FC236}">
-                <a16:creationId xmlns:a16="http://schemas.microsoft.com/office/drawing/2014/main" id="{E58126C8-D66B-4A3A-B9C6-CF585C558AC1}"/>
+                <a16:creationId xmlns:a16="http://schemas.microsoft.com/office/drawing/2014/main" id="{FFEFD901-FC6D-485B-B461-0C30DB4BDB32}"/>
               </a:ext>
             </a:extLst>
           </p:cNvPr>
@@ -24585,7 +24835,7 @@
           <p:cNvPr id="10" name="explicit-representation">
             <a:extLst xmlns:a="http://schemas.openxmlformats.org/drawingml/2006/main">
               <a:ext uri="{FF2B5EF4-FFF2-40B4-BE49-F238E27FC236}">
-                <a16:creationId xmlns:a16="http://schemas.microsoft.com/office/drawing/2014/main" id="{97A53243-A5B0-46E4-82D2-849941B1A147}"/>
+                <a16:creationId xmlns:a16="http://schemas.microsoft.com/office/drawing/2014/main" id="{CCCD08A0-2FEB-400E-96B8-0A749C81B244}"/>
               </a:ext>
             </a:extLst>
           </p:cNvPr>
@@ -24794,7 +25044,7 @@
           <p:cNvPr id="18" name="cnn-depth-disclosure">
             <a:extLst xmlns:a="http://schemas.openxmlformats.org/drawingml/2006/main">
               <a:ext uri="{FF2B5EF4-FFF2-40B4-BE49-F238E27FC236}">
-                <a16:creationId xmlns:a16="http://schemas.microsoft.com/office/drawing/2014/main" id="{1DD5664A-2706-4C03-A60B-81E55FECE97D}"/>
+                <a16:creationId xmlns:a16="http://schemas.microsoft.com/office/drawing/2014/main" id="{FC658BC1-06DC-49BD-AE1A-95A0623D3676}"/>
               </a:ext>
             </a:extLst>
           </p:cNvPr>
@@ -24951,7 +25201,7 @@
     </p:spTree>
     <p:extLst>
       <p:ext uri="{BB962C8B-B14F-4D97-AF65-F5344CB8AC3E}">
-        <p14:creationId xmlns:p14="http://schemas.microsoft.com/office/powerpoint/2010/main" val="1558389914"/>
+        <p14:creationId xmlns:p14="http://schemas.microsoft.com/office/powerpoint/2010/main" val="825100074"/>
       </p:ext>
     </p:extLst>
   </p:cSld>
@@ -24982,7 +25232,7 @@
           <p:cNvPr id="23" name="">
             <a:extLst xmlns:a="http://schemas.openxmlformats.org/drawingml/2006/main">
               <a:ext uri="{FF2B5EF4-FFF2-40B4-BE49-F238E27FC236}">
-                <a16:creationId xmlns:a16="http://schemas.microsoft.com/office/drawing/2014/main" id="{33CDAA1A-D430-4FD3-AFD7-7A67A8E82158}"/>
+                <a16:creationId xmlns:a16="http://schemas.microsoft.com/office/drawing/2014/main" id="{8D362B1D-19D6-4D20-8669-E683BA4ED9EF}"/>
               </a:ext>
             </a:extLst>
           </p:cNvPr>
@@ -25015,7 +25265,7 @@
           <p:cNvPr id="22" name="">
             <a:extLst xmlns:a="http://schemas.openxmlformats.org/drawingml/2006/main">
               <a:ext uri="{FF2B5EF4-FFF2-40B4-BE49-F238E27FC236}">
-                <a16:creationId xmlns:a16="http://schemas.microsoft.com/office/drawing/2014/main" id="{4F447A5D-9402-4E1F-BC33-1AD798DD0B66}"/>
+                <a16:creationId xmlns:a16="http://schemas.microsoft.com/office/drawing/2014/main" id="{596810F8-8A51-4DCD-89AD-5BDACB780460}"/>
               </a:ext>
             </a:extLst>
           </p:cNvPr>
@@ -25048,7 +25298,7 @@
           <p:cNvPr id="21" name="">
             <a:extLst xmlns:a="http://schemas.openxmlformats.org/drawingml/2006/main">
               <a:ext uri="{FF2B5EF4-FFF2-40B4-BE49-F238E27FC236}">
-                <a16:creationId xmlns:a16="http://schemas.microsoft.com/office/drawing/2014/main" id="{286F3A82-5ECA-45BA-BBCC-46F4EA16F283}"/>
+                <a16:creationId xmlns:a16="http://schemas.microsoft.com/office/drawing/2014/main" id="{56B4C96B-DB2B-45F9-BDFD-EA516CCE3903}"/>
               </a:ext>
             </a:extLst>
           </p:cNvPr>
@@ -25081,7 +25331,7 @@
           <p:cNvPr id="20" name="">
             <a:extLst xmlns:a="http://schemas.openxmlformats.org/drawingml/2006/main">
               <a:ext uri="{FF2B5EF4-FFF2-40B4-BE49-F238E27FC236}">
-                <a16:creationId xmlns:a16="http://schemas.microsoft.com/office/drawing/2014/main" id="{BD02F616-A9BB-4828-8177-799718397CBA}"/>
+                <a16:creationId xmlns:a16="http://schemas.microsoft.com/office/drawing/2014/main" id="{317408F1-0CD2-4B18-8438-AC4073D65B10}"/>
               </a:ext>
             </a:extLst>
           </p:cNvPr>
@@ -25114,7 +25364,7 @@
           <p:cNvPr id="19" name="">
             <a:extLst xmlns:a="http://schemas.openxmlformats.org/drawingml/2006/main">
               <a:ext uri="{FF2B5EF4-FFF2-40B4-BE49-F238E27FC236}">
-                <a16:creationId xmlns:a16="http://schemas.microsoft.com/office/drawing/2014/main" id="{E3E1333D-C9F5-454C-8147-13E6D7218B4B}"/>
+                <a16:creationId xmlns:a16="http://schemas.microsoft.com/office/drawing/2014/main" id="{4BD1461A-2B56-473F-B54C-77FB39AE5B75}"/>
               </a:ext>
             </a:extLst>
           </p:cNvPr>
@@ -25147,7 +25397,7 @@
           <p:cNvPr id="18" name="">
             <a:extLst xmlns:a="http://schemas.openxmlformats.org/drawingml/2006/main">
               <a:ext uri="{FF2B5EF4-FFF2-40B4-BE49-F238E27FC236}">
-                <a16:creationId xmlns:a16="http://schemas.microsoft.com/office/drawing/2014/main" id="{EC9854F0-D701-4287-9524-10FE65D9D994}"/>
+                <a16:creationId xmlns:a16="http://schemas.microsoft.com/office/drawing/2014/main" id="{92B82CBB-544E-476D-B4DF-AD5A07A77A55}"/>
               </a:ext>
             </a:extLst>
           </p:cNvPr>
@@ -25182,7 +25432,7 @@
           <p:cNvPr id="17" name="">
             <a:extLst xmlns:a="http://schemas.openxmlformats.org/drawingml/2006/main">
               <a:ext uri="{FF2B5EF4-FFF2-40B4-BE49-F238E27FC236}">
-                <a16:creationId xmlns:a16="http://schemas.microsoft.com/office/drawing/2014/main" id="{D2F99617-E865-43B1-BA8A-A4DAC95E6D1B}"/>
+                <a16:creationId xmlns:a16="http://schemas.microsoft.com/office/drawing/2014/main" id="{F756B211-7D67-4E4E-AF98-B483FF80C8CA}"/>
               </a:ext>
             </a:extLst>
           </p:cNvPr>
@@ -25217,7 +25467,7 @@
           <p:cNvPr id="16" name="">
             <a:extLst xmlns:a="http://schemas.openxmlformats.org/drawingml/2006/main">
               <a:ext uri="{FF2B5EF4-FFF2-40B4-BE49-F238E27FC236}">
-                <a16:creationId xmlns:a16="http://schemas.microsoft.com/office/drawing/2014/main" id="{C7846CD3-1D23-41E5-A677-6BE8946BDEA3}"/>
+                <a16:creationId xmlns:a16="http://schemas.microsoft.com/office/drawing/2014/main" id="{78783766-C384-4066-9A54-D38123B43F61}"/>
               </a:ext>
             </a:extLst>
           </p:cNvPr>
@@ -25252,7 +25502,7 @@
           <p:cNvPr id="15" name="">
             <a:extLst xmlns:a="http://schemas.openxmlformats.org/drawingml/2006/main">
               <a:ext uri="{FF2B5EF4-FFF2-40B4-BE49-F238E27FC236}">
-                <a16:creationId xmlns:a16="http://schemas.microsoft.com/office/drawing/2014/main" id="{35033477-8F19-478F-8AE5-653F48F42CD7}"/>
+                <a16:creationId xmlns:a16="http://schemas.microsoft.com/office/drawing/2014/main" id="{D74D81F6-F823-4FC6-9578-88B0F63F07AB}"/>
               </a:ext>
             </a:extLst>
           </p:cNvPr>
@@ -25287,7 +25537,7 @@
           <p:cNvPr id="14" name="">
             <a:extLst xmlns:a="http://schemas.openxmlformats.org/drawingml/2006/main">
               <a:ext uri="{FF2B5EF4-FFF2-40B4-BE49-F238E27FC236}">
-                <a16:creationId xmlns:a16="http://schemas.microsoft.com/office/drawing/2014/main" id="{19863004-D4BB-4D18-B960-28AFD831026A}"/>
+                <a16:creationId xmlns:a16="http://schemas.microsoft.com/office/drawing/2014/main" id="{339C9BED-1277-4C65-8934-62321B7103C9}"/>
               </a:ext>
             </a:extLst>
           </p:cNvPr>
@@ -25322,7 +25572,7 @@
           <p:cNvPr id="26" name="slide-title">
             <a:extLst xmlns:a="http://schemas.openxmlformats.org/drawingml/2006/main">
               <a:ext uri="{FF2B5EF4-FFF2-40B4-BE49-F238E27FC236}">
-                <a16:creationId xmlns:a16="http://schemas.microsoft.com/office/drawing/2014/main" id="{80FE678A-FB2E-40B7-B4EF-E97F5121CA14}"/>
+                <a16:creationId xmlns:a16="http://schemas.microsoft.com/office/drawing/2014/main" id="{07B09D14-4C3D-4144-AB8D-8DE76FC8E374}"/>
               </a:ext>
             </a:extLst>
           </p:cNvPr>
@@ -25481,7 +25731,7 @@
           <p:cNvPr id="2" name="divider">
             <a:extLst xmlns:a="http://schemas.openxmlformats.org/drawingml/2006/main">
               <a:ext uri="{FF2B5EF4-FFF2-40B4-BE49-F238E27FC236}">
-                <a16:creationId xmlns:a16="http://schemas.microsoft.com/office/drawing/2014/main" id="{78F4A995-6742-45E4-89F9-C645DB105735}"/>
+                <a16:creationId xmlns:a16="http://schemas.microsoft.com/office/drawing/2014/main" id="{6A1A2C75-04D2-4CE3-ACFA-157C3ED3B782}"/>
               </a:ext>
             </a:extLst>
           </p:cNvPr>
@@ -25514,7 +25764,7 @@
           <p:cNvPr id="3" name="slide-subtitle">
             <a:extLst xmlns:a="http://schemas.openxmlformats.org/drawingml/2006/main">
               <a:ext uri="{FF2B5EF4-FFF2-40B4-BE49-F238E27FC236}">
-                <a16:creationId xmlns:a16="http://schemas.microsoft.com/office/drawing/2014/main" id="{F5E123FA-DF65-4139-9741-0BC3080423B4}"/>
+                <a16:creationId xmlns:a16="http://schemas.microsoft.com/office/drawing/2014/main" id="{DB6A7388-5F64-4FF8-8300-2B0B721C0787}"/>
               </a:ext>
             </a:extLst>
           </p:cNvPr>
@@ -25673,7 +25923,7 @@
           <p:cNvPr id="4" name="implemented-side-input">
             <a:extLst xmlns:a="http://schemas.openxmlformats.org/drawingml/2006/main">
               <a:ext uri="{FF2B5EF4-FFF2-40B4-BE49-F238E27FC236}">
-                <a16:creationId xmlns:a16="http://schemas.microsoft.com/office/drawing/2014/main" id="{FA077987-9162-4B91-9C1A-FC1D0ED4D22A}"/>
+                <a16:creationId xmlns:a16="http://schemas.microsoft.com/office/drawing/2014/main" id="{2E0C725C-6C25-4633-9C44-405E4B620EE8}"/>
               </a:ext>
             </a:extLst>
           </p:cNvPr>
@@ -25882,7 +26132,7 @@
           <p:cNvPr id="5" name="implemented-id-input">
             <a:extLst xmlns:a="http://schemas.openxmlformats.org/drawingml/2006/main">
               <a:ext uri="{FF2B5EF4-FFF2-40B4-BE49-F238E27FC236}">
-                <a16:creationId xmlns:a16="http://schemas.microsoft.com/office/drawing/2014/main" id="{00A273FE-F999-4C84-A40A-72712AD38260}"/>
+                <a16:creationId xmlns:a16="http://schemas.microsoft.com/office/drawing/2014/main" id="{9D165AB1-D310-4961-8699-15A4ACEE38E2}"/>
               </a:ext>
             </a:extLst>
           </p:cNvPr>
@@ -26068,7 +26318,7 @@
           <p:cNvPr id="6" name="local-72">
             <a:extLst xmlns:a="http://schemas.openxmlformats.org/drawingml/2006/main">
               <a:ext uri="{FF2B5EF4-FFF2-40B4-BE49-F238E27FC236}">
-                <a16:creationId xmlns:a16="http://schemas.microsoft.com/office/drawing/2014/main" id="{3A287743-115C-4210-9696-994A67DE62E7}"/>
+                <a16:creationId xmlns:a16="http://schemas.microsoft.com/office/drawing/2014/main" id="{56B58FB8-AC98-4891-A216-3915602D90FE}"/>
               </a:ext>
             </a:extLst>
           </p:cNvPr>
@@ -26254,7 +26504,7 @@
           <p:cNvPr id="7" name="global-64">
             <a:extLst xmlns:a="http://schemas.openxmlformats.org/drawingml/2006/main">
               <a:ext uri="{FF2B5EF4-FFF2-40B4-BE49-F238E27FC236}">
-                <a16:creationId xmlns:a16="http://schemas.microsoft.com/office/drawing/2014/main" id="{C8D43243-BECB-4FD8-93A7-D2BB6B2EC937}"/>
+                <a16:creationId xmlns:a16="http://schemas.microsoft.com/office/drawing/2014/main" id="{6640FEDC-1953-4AB3-8446-B095E691254F}"/>
               </a:ext>
             </a:extLst>
           </p:cNvPr>
@@ -26440,7 +26690,7 @@
           <p:cNvPr id="8" name="implicit-64">
             <a:extLst xmlns:a="http://schemas.openxmlformats.org/drawingml/2006/main">
               <a:ext uri="{FF2B5EF4-FFF2-40B4-BE49-F238E27FC236}">
-                <a16:creationId xmlns:a16="http://schemas.microsoft.com/office/drawing/2014/main" id="{C4ABE314-C2BB-491B-A2BB-C7742D97E63D}"/>
+                <a16:creationId xmlns:a16="http://schemas.microsoft.com/office/drawing/2014/main" id="{4F4B28E8-6CEB-4C5F-B342-77D30DE46D6E}"/>
               </a:ext>
             </a:extLst>
           </p:cNvPr>
@@ -26649,7 +26899,7 @@
           <p:cNvPr id="9" name="explicit-concat-136">
             <a:extLst xmlns:a="http://schemas.openxmlformats.org/drawingml/2006/main">
               <a:ext uri="{FF2B5EF4-FFF2-40B4-BE49-F238E27FC236}">
-                <a16:creationId xmlns:a16="http://schemas.microsoft.com/office/drawing/2014/main" id="{B05BCD18-A3B6-499A-8302-11EED2014F6C}"/>
+                <a16:creationId xmlns:a16="http://schemas.microsoft.com/office/drawing/2014/main" id="{15693E24-5A81-4FEF-AE6F-1865994B2278}"/>
               </a:ext>
             </a:extLst>
           </p:cNvPr>
@@ -26858,7 +27108,7 @@
           <p:cNvPr id="10" name="explicit-fusion-64">
             <a:extLst xmlns:a="http://schemas.openxmlformats.org/drawingml/2006/main">
               <a:ext uri="{FF2B5EF4-FFF2-40B4-BE49-F238E27FC236}">
-                <a16:creationId xmlns:a16="http://schemas.microsoft.com/office/drawing/2014/main" id="{B6229971-5E02-4825-867C-6B42D5B6C170}"/>
+                <a16:creationId xmlns:a16="http://schemas.microsoft.com/office/drawing/2014/main" id="{89BEFCF7-11AB-4C36-985F-077032952340}"/>
               </a:ext>
             </a:extLst>
           </p:cNvPr>
@@ -27044,7 +27294,7 @@
           <p:cNvPr id="11" name="joint-concat-128">
             <a:extLst xmlns:a="http://schemas.openxmlformats.org/drawingml/2006/main">
               <a:ext uri="{FF2B5EF4-FFF2-40B4-BE49-F238E27FC236}">
-                <a16:creationId xmlns:a16="http://schemas.microsoft.com/office/drawing/2014/main" id="{AF592F3E-C89C-4222-B2E4-46529EA50851}"/>
+                <a16:creationId xmlns:a16="http://schemas.microsoft.com/office/drawing/2014/main" id="{12EB4E85-08C3-4E22-B76B-388A04F34E86}"/>
               </a:ext>
             </a:extLst>
           </p:cNvPr>
@@ -27253,7 +27503,7 @@
           <p:cNvPr id="12" name="joint-fusion-64">
             <a:extLst xmlns:a="http://schemas.openxmlformats.org/drawingml/2006/main">
               <a:ext uri="{FF2B5EF4-FFF2-40B4-BE49-F238E27FC236}">
-                <a16:creationId xmlns:a16="http://schemas.microsoft.com/office/drawing/2014/main" id="{F4E75DAB-6958-44E8-B8DC-EE34AC1BE13D}"/>
+                <a16:creationId xmlns:a16="http://schemas.microsoft.com/office/drawing/2014/main" id="{9FAB5E05-2029-4CC4-9781-6D44D95F7199}"/>
               </a:ext>
             </a:extLst>
           </p:cNvPr>
@@ -27439,7 +27689,7 @@
           <p:cNvPr id="13" name="score-output">
             <a:extLst xmlns:a="http://schemas.openxmlformats.org/drawingml/2006/main">
               <a:ext uri="{FF2B5EF4-FFF2-40B4-BE49-F238E27FC236}">
-                <a16:creationId xmlns:a16="http://schemas.microsoft.com/office/drawing/2014/main" id="{6541D3D4-06E9-46D6-BD4F-053B80063565}"/>
+                <a16:creationId xmlns:a16="http://schemas.microsoft.com/office/drawing/2014/main" id="{D799D455-395A-48E5-A979-34688A3F006A}"/>
               </a:ext>
             </a:extLst>
           </p:cNvPr>
@@ -27625,7 +27875,7 @@
           <p:cNvPr id="24" name="coupled-local-shape">
             <a:extLst xmlns:a="http://schemas.openxmlformats.org/drawingml/2006/main">
               <a:ext uri="{FF2B5EF4-FFF2-40B4-BE49-F238E27FC236}">
-                <a16:creationId xmlns:a16="http://schemas.microsoft.com/office/drawing/2014/main" id="{3B33A6A4-1619-47CE-969D-D358299BC60F}"/>
+                <a16:creationId xmlns:a16="http://schemas.microsoft.com/office/drawing/2014/main" id="{BA1C5E79-6E68-43E4-BFB5-F088EBF2AB8C}"/>
               </a:ext>
             </a:extLst>
           </p:cNvPr>
@@ -27784,7 +28034,7 @@
           <p:cNvPr id="25" name="scorer-loss">
             <a:extLst xmlns:a="http://schemas.openxmlformats.org/drawingml/2006/main">
               <a:ext uri="{FF2B5EF4-FFF2-40B4-BE49-F238E27FC236}">
-                <a16:creationId xmlns:a16="http://schemas.microsoft.com/office/drawing/2014/main" id="{CEA37FC9-59C7-4D23-86B4-B52B95365C6C}"/>
+                <a16:creationId xmlns:a16="http://schemas.microsoft.com/office/drawing/2014/main" id="{21734429-7970-48D3-9963-C418511B77E6}"/>
               </a:ext>
             </a:extLst>
           </p:cNvPr>
@@ -27941,7 +28191,7 @@
     </p:spTree>
     <p:extLst>
       <p:ext uri="{BB962C8B-B14F-4D97-AF65-F5344CB8AC3E}">
-        <p14:creationId xmlns:p14="http://schemas.microsoft.com/office/powerpoint/2010/main" val="869035686"/>
+        <p14:creationId xmlns:p14="http://schemas.microsoft.com/office/powerpoint/2010/main" val="2112492303"/>
       </p:ext>
     </p:extLst>
   </p:cSld>
@@ -27972,7 +28222,7 @@
           <p:cNvPr id="19" name="slide-title">
             <a:extLst xmlns:a="http://schemas.openxmlformats.org/drawingml/2006/main">
               <a:ext uri="{FF2B5EF4-FFF2-40B4-BE49-F238E27FC236}">
-                <a16:creationId xmlns:a16="http://schemas.microsoft.com/office/drawing/2014/main" id="{98A509C0-50BD-42D2-B933-FB653D835640}"/>
+                <a16:creationId xmlns:a16="http://schemas.microsoft.com/office/drawing/2014/main" id="{7712D04C-A618-48F1-AB4D-91D9559F59D5}"/>
               </a:ext>
             </a:extLst>
           </p:cNvPr>
@@ -28131,7 +28381,7 @@
           <p:cNvPr id="2" name="divider">
             <a:extLst xmlns:a="http://schemas.openxmlformats.org/drawingml/2006/main">
               <a:ext uri="{FF2B5EF4-FFF2-40B4-BE49-F238E27FC236}">
-                <a16:creationId xmlns:a16="http://schemas.microsoft.com/office/drawing/2014/main" id="{94709ABF-7557-416C-9787-6B93C2BA2A2A}"/>
+                <a16:creationId xmlns:a16="http://schemas.microsoft.com/office/drawing/2014/main" id="{9ACA4EA2-187E-4AC9-99A0-390B2A261003}"/>
               </a:ext>
             </a:extLst>
           </p:cNvPr>
@@ -28164,7 +28414,7 @@
           <p:cNvPr id="3" name="slide-subtitle">
             <a:extLst xmlns:a="http://schemas.openxmlformats.org/drawingml/2006/main">
               <a:ext uri="{FF2B5EF4-FFF2-40B4-BE49-F238E27FC236}">
-                <a16:creationId xmlns:a16="http://schemas.microsoft.com/office/drawing/2014/main" id="{46DA6B1C-1FBB-4278-AF60-597DA52063A3}"/>
+                <a16:creationId xmlns:a16="http://schemas.microsoft.com/office/drawing/2014/main" id="{C5DA8F66-0EAF-41C0-8680-B8FF165E2D35}"/>
               </a:ext>
             </a:extLst>
           </p:cNvPr>
@@ -28323,7 +28573,7 @@
           <p:cNvPr id="4" name="dataset-stat">
             <a:extLst xmlns:a="http://schemas.openxmlformats.org/drawingml/2006/main">
               <a:ext uri="{FF2B5EF4-FFF2-40B4-BE49-F238E27FC236}">
-                <a16:creationId xmlns:a16="http://schemas.microsoft.com/office/drawing/2014/main" id="{113E0F62-96E4-4E7B-9083-364B1DD5FF51}"/>
+                <a16:creationId xmlns:a16="http://schemas.microsoft.com/office/drawing/2014/main" id="{1DEC9B3C-4E8D-4A77-944B-53ABC1DFED83}"/>
               </a:ext>
             </a:extLst>
           </p:cNvPr>
@@ -28482,7 +28732,7 @@
           <p:cNvPr id="5" name="dataset-stat-label">
             <a:extLst xmlns:a="http://schemas.openxmlformats.org/drawingml/2006/main">
               <a:ext uri="{FF2B5EF4-FFF2-40B4-BE49-F238E27FC236}">
-                <a16:creationId xmlns:a16="http://schemas.microsoft.com/office/drawing/2014/main" id="{2ED11148-22B4-4438-8DA9-64517E1DB6F4}"/>
+                <a16:creationId xmlns:a16="http://schemas.microsoft.com/office/drawing/2014/main" id="{02AA308C-4B9C-458D-8F00-7A7497BFC873}"/>
               </a:ext>
             </a:extLst>
           </p:cNvPr>
@@ -28641,7 +28891,7 @@
           <p:cNvPr id="6" name="dataset-stat">
             <a:extLst xmlns:a="http://schemas.openxmlformats.org/drawingml/2006/main">
               <a:ext uri="{FF2B5EF4-FFF2-40B4-BE49-F238E27FC236}">
-                <a16:creationId xmlns:a16="http://schemas.microsoft.com/office/drawing/2014/main" id="{0E7D6D1D-41E5-40AB-A8E4-567B281230A6}"/>
+                <a16:creationId xmlns:a16="http://schemas.microsoft.com/office/drawing/2014/main" id="{C7CCBB20-3B82-4A15-A418-A39D84889ACB}"/>
               </a:ext>
             </a:extLst>
           </p:cNvPr>
@@ -28800,7 +29050,7 @@
           <p:cNvPr id="7" name="dataset-stat-label">
             <a:extLst xmlns:a="http://schemas.openxmlformats.org/drawingml/2006/main">
               <a:ext uri="{FF2B5EF4-FFF2-40B4-BE49-F238E27FC236}">
-                <a16:creationId xmlns:a16="http://schemas.microsoft.com/office/drawing/2014/main" id="{330ADB33-D9A9-40C5-A6EC-D733680BC9F8}"/>
+                <a16:creationId xmlns:a16="http://schemas.microsoft.com/office/drawing/2014/main" id="{C29D6CB7-06BA-48B2-97E9-841EF44C4D07}"/>
               </a:ext>
             </a:extLst>
           </p:cNvPr>
@@ -28959,7 +29209,7 @@
           <p:cNvPr id="8" name="dataset-stat">
             <a:extLst xmlns:a="http://schemas.openxmlformats.org/drawingml/2006/main">
               <a:ext uri="{FF2B5EF4-FFF2-40B4-BE49-F238E27FC236}">
-                <a16:creationId xmlns:a16="http://schemas.microsoft.com/office/drawing/2014/main" id="{A3497474-56B7-468C-A3B5-B041C88F93D9}"/>
+                <a16:creationId xmlns:a16="http://schemas.microsoft.com/office/drawing/2014/main" id="{C454935A-D934-4D6A-A954-E737348461DE}"/>
               </a:ext>
             </a:extLst>
           </p:cNvPr>
@@ -29118,7 +29368,7 @@
           <p:cNvPr id="9" name="dataset-stat-label">
             <a:extLst xmlns:a="http://schemas.openxmlformats.org/drawingml/2006/main">
               <a:ext uri="{FF2B5EF4-FFF2-40B4-BE49-F238E27FC236}">
-                <a16:creationId xmlns:a16="http://schemas.microsoft.com/office/drawing/2014/main" id="{991D6131-62A1-411F-8AE1-B531B6029312}"/>
+                <a16:creationId xmlns:a16="http://schemas.microsoft.com/office/drawing/2014/main" id="{FCC0DA7A-4EEE-479C-8683-4A4CB65C0B64}"/>
               </a:ext>
             </a:extLst>
           </p:cNvPr>
@@ -29277,7 +29527,7 @@
           <p:cNvPr id="10" name="divider">
             <a:extLst xmlns:a="http://schemas.openxmlformats.org/drawingml/2006/main">
               <a:ext uri="{FF2B5EF4-FFF2-40B4-BE49-F238E27FC236}">
-                <a16:creationId xmlns:a16="http://schemas.microsoft.com/office/drawing/2014/main" id="{21EA06FE-B366-4697-8219-B787C75A81CA}"/>
+                <a16:creationId xmlns:a16="http://schemas.microsoft.com/office/drawing/2014/main" id="{C0ECF392-F7D0-4E06-928A-15E016507B48}"/>
               </a:ext>
             </a:extLst>
           </p:cNvPr>
@@ -29310,7 +29560,7 @@
           <p:cNvPr id="11" name="section-heading">
             <a:extLst xmlns:a="http://schemas.openxmlformats.org/drawingml/2006/main">
               <a:ext uri="{FF2B5EF4-FFF2-40B4-BE49-F238E27FC236}">
-                <a16:creationId xmlns:a16="http://schemas.microsoft.com/office/drawing/2014/main" id="{BB7B48AF-345D-4591-93AE-A63ADCB5A5EF}"/>
+                <a16:creationId xmlns:a16="http://schemas.microsoft.com/office/drawing/2014/main" id="{CF9EB459-4D0F-43E5-95EE-381689F378D6}"/>
               </a:ext>
             </a:extLst>
           </p:cNvPr>
@@ -29469,7 +29719,7 @@
           <p:cNvPr id="12" name="train-count">
             <a:extLst xmlns:a="http://schemas.openxmlformats.org/drawingml/2006/main">
               <a:ext uri="{FF2B5EF4-FFF2-40B4-BE49-F238E27FC236}">
-                <a16:creationId xmlns:a16="http://schemas.microsoft.com/office/drawing/2014/main" id="{7C1B1824-93CE-495B-90FD-E071B5B72F93}"/>
+                <a16:creationId xmlns:a16="http://schemas.microsoft.com/office/drawing/2014/main" id="{FF3801C3-E514-4505-9E69-A10B9B7479AC}"/>
               </a:ext>
             </a:extLst>
           </p:cNvPr>
@@ -29628,7 +29878,7 @@
           <p:cNvPr id="13" name="heldout-count">
             <a:extLst xmlns:a="http://schemas.openxmlformats.org/drawingml/2006/main">
               <a:ext uri="{FF2B5EF4-FFF2-40B4-BE49-F238E27FC236}">
-                <a16:creationId xmlns:a16="http://schemas.microsoft.com/office/drawing/2014/main" id="{EBBE9C34-AAE6-4F7F-8772-F0ADC1435BD5}"/>
+                <a16:creationId xmlns:a16="http://schemas.microsoft.com/office/drawing/2014/main" id="{09A4294B-ED5B-4675-9A99-203EC37F9D26}"/>
               </a:ext>
             </a:extLst>
           </p:cNvPr>
@@ -29787,7 +30037,7 @@
           <p:cNvPr id="14" name="training-sampling">
             <a:extLst xmlns:a="http://schemas.openxmlformats.org/drawingml/2006/main">
               <a:ext uri="{FF2B5EF4-FFF2-40B4-BE49-F238E27FC236}">
-                <a16:creationId xmlns:a16="http://schemas.microsoft.com/office/drawing/2014/main" id="{680230DA-0926-42F5-A69D-64B665CBE9C9}"/>
+                <a16:creationId xmlns:a16="http://schemas.microsoft.com/office/drawing/2014/main" id="{0DB36A8D-5B47-4D12-BB30-541BEDCFA9DC}"/>
               </a:ext>
             </a:extLst>
           </p:cNvPr>
@@ -29946,7 +30196,7 @@
           <p:cNvPr id="15" name="section-heading">
             <a:extLst xmlns:a="http://schemas.openxmlformats.org/drawingml/2006/main">
               <a:ext uri="{FF2B5EF4-FFF2-40B4-BE49-F238E27FC236}">
-                <a16:creationId xmlns:a16="http://schemas.microsoft.com/office/drawing/2014/main" id="{40680453-FF34-4053-B683-3560D224BC9E}"/>
+                <a16:creationId xmlns:a16="http://schemas.microsoft.com/office/drawing/2014/main" id="{6AC785DB-7810-43B0-8FEA-9C78AF783A59}"/>
               </a:ext>
             </a:extLst>
           </p:cNvPr>
@@ -30105,7 +30355,7 @@
           <p:cNvPr id="16" name="candidate-count">
             <a:extLst xmlns:a="http://schemas.openxmlformats.org/drawingml/2006/main">
               <a:ext uri="{FF2B5EF4-FFF2-40B4-BE49-F238E27FC236}">
-                <a16:creationId xmlns:a16="http://schemas.microsoft.com/office/drawing/2014/main" id="{FDECB86E-675C-4E09-B558-BAC970F2367C}"/>
+                <a16:creationId xmlns:a16="http://schemas.microsoft.com/office/drawing/2014/main" id="{3D1DF884-0C6C-4E41-83D1-5AB1026AF1AB}"/>
               </a:ext>
             </a:extLst>
           </p:cNvPr>
@@ -30264,7 +30514,7 @@
           <p:cNvPr id="17" name="ranking-protocol">
             <a:extLst xmlns:a="http://schemas.openxmlformats.org/drawingml/2006/main">
               <a:ext uri="{FF2B5EF4-FFF2-40B4-BE49-F238E27FC236}">
-                <a16:creationId xmlns:a16="http://schemas.microsoft.com/office/drawing/2014/main" id="{D5DDE17C-CE9B-47B0-AB83-094175CC324F}"/>
+                <a16:creationId xmlns:a16="http://schemas.microsoft.com/office/drawing/2014/main" id="{123DCC9F-38A2-46D7-8149-2251A9730D8F}"/>
               </a:ext>
             </a:extLst>
           </p:cNvPr>
@@ -30423,7 +30673,7 @@
           <p:cNvPr id="18" name="seed-protocol">
             <a:extLst xmlns:a="http://schemas.openxmlformats.org/drawingml/2006/main">
               <a:ext uri="{FF2B5EF4-FFF2-40B4-BE49-F238E27FC236}">
-                <a16:creationId xmlns:a16="http://schemas.microsoft.com/office/drawing/2014/main" id="{AC0BD86B-6558-43FF-8A78-6EAE8A9DDEDC}"/>
+                <a16:creationId xmlns:a16="http://schemas.microsoft.com/office/drawing/2014/main" id="{5ED0D3CE-9ADD-418A-A88E-7208F39777FF}"/>
               </a:ext>
             </a:extLst>
           </p:cNvPr>
@@ -30580,7 +30830,7 @@
     </p:spTree>
     <p:extLst>
       <p:ext uri="{BB962C8B-B14F-4D97-AF65-F5344CB8AC3E}">
-        <p14:creationId xmlns:p14="http://schemas.microsoft.com/office/powerpoint/2010/main" val="1033664420"/>
+        <p14:creationId xmlns:p14="http://schemas.microsoft.com/office/powerpoint/2010/main" val="1692466767"/>
       </p:ext>
     </p:extLst>
   </p:cSld>
@@ -30611,7 +30861,7 @@
           <p:cNvPr id="7" name="slide-title">
             <a:extLst xmlns:a="http://schemas.openxmlformats.org/drawingml/2006/main">
               <a:ext uri="{FF2B5EF4-FFF2-40B4-BE49-F238E27FC236}">
-                <a16:creationId xmlns:a16="http://schemas.microsoft.com/office/drawing/2014/main" id="{E45672B8-9181-4C0D-901D-CF7F3B9D69F9}"/>
+                <a16:creationId xmlns:a16="http://schemas.microsoft.com/office/drawing/2014/main" id="{2935FB9A-4086-487E-9567-F61C9FC04849}"/>
               </a:ext>
             </a:extLst>
           </p:cNvPr>
@@ -30770,7 +31020,7 @@
           <p:cNvPr id="2" name="divider">
             <a:extLst xmlns:a="http://schemas.openxmlformats.org/drawingml/2006/main">
               <a:ext uri="{FF2B5EF4-FFF2-40B4-BE49-F238E27FC236}">
-                <a16:creationId xmlns:a16="http://schemas.microsoft.com/office/drawing/2014/main" id="{7A67A334-FF16-491A-B2B3-F3338F50553E}"/>
+                <a16:creationId xmlns:a16="http://schemas.microsoft.com/office/drawing/2014/main" id="{7E4EB5F3-EEFB-4F7E-9EFB-FBA0F6D7A891}"/>
               </a:ext>
             </a:extLst>
           </p:cNvPr>
@@ -30803,7 +31053,7 @@
           <p:cNvPr id="3" name="slide-subtitle">
             <a:extLst xmlns:a="http://schemas.openxmlformats.org/drawingml/2006/main">
               <a:ext uri="{FF2B5EF4-FFF2-40B4-BE49-F238E27FC236}">
-                <a16:creationId xmlns:a16="http://schemas.microsoft.com/office/drawing/2014/main" id="{428E59D5-50D8-4552-BC38-3BCE1781F687}"/>
+                <a16:creationId xmlns:a16="http://schemas.microsoft.com/office/drawing/2014/main" id="{7E1B8BE7-9C83-4DC4-9309-3E34F77BDDA6}"/>
               </a:ext>
             </a:extLst>
           </p:cNvPr>
@@ -30962,7 +31212,7 @@
           <p:cNvPr id="4" name="">
             <a:extLst xmlns:a="http://schemas.openxmlformats.org/drawingml/2006/main">
               <a:ext uri="{FF2B5EF4-FFF2-40B4-BE49-F238E27FC236}">
-                <a16:creationId xmlns:a16="http://schemas.microsoft.com/office/drawing/2014/main" id="{A74B2BDD-7338-4614-A123-22EE9262D4F0}"/>
+                <a16:creationId xmlns:a16="http://schemas.microsoft.com/office/drawing/2014/main" id="{D700C99D-38C4-4CAA-963C-7428B31E285F}"/>
               </a:ext>
             </a:extLst>
           </p:cNvPr>
@@ -32000,7 +32250,7 @@
           <p:cNvPr id="5" name="training-budget">
             <a:extLst xmlns:a="http://schemas.openxmlformats.org/drawingml/2006/main">
               <a:ext uri="{FF2B5EF4-FFF2-40B4-BE49-F238E27FC236}">
-                <a16:creationId xmlns:a16="http://schemas.microsoft.com/office/drawing/2014/main" id="{69054D0E-5C3F-4926-B7BE-B561F2AAE993}"/>
+                <a16:creationId xmlns:a16="http://schemas.microsoft.com/office/drawing/2014/main" id="{A72D62D7-343D-45A4-B8D0-8A6449C67F38}"/>
               </a:ext>
             </a:extLst>
           </p:cNvPr>
@@ -32159,7 +32409,7 @@
           <p:cNvPr id="6" name="checkpoint-selection">
             <a:extLst xmlns:a="http://schemas.openxmlformats.org/drawingml/2006/main">
               <a:ext uri="{FF2B5EF4-FFF2-40B4-BE49-F238E27FC236}">
-                <a16:creationId xmlns:a16="http://schemas.microsoft.com/office/drawing/2014/main" id="{A38D8B64-E8D3-4FC9-A624-0D1D96FEFF91}"/>
+                <a16:creationId xmlns:a16="http://schemas.microsoft.com/office/drawing/2014/main" id="{EB3C99DE-F926-4C2A-B756-37636316BB5E}"/>
               </a:ext>
             </a:extLst>
           </p:cNvPr>
@@ -32316,7 +32566,7 @@
     </p:spTree>
     <p:extLst>
       <p:ext uri="{BB962C8B-B14F-4D97-AF65-F5344CB8AC3E}">
-        <p14:creationId xmlns:p14="http://schemas.microsoft.com/office/powerpoint/2010/main" val="270051644"/>
+        <p14:creationId xmlns:p14="http://schemas.microsoft.com/office/powerpoint/2010/main" val="193718052"/>
       </p:ext>
     </p:extLst>
   </p:cSld>

</xml_diff>